<commit_message>
Auto-condemn instrument on fault log; update RISE presentation for QI pitch
- logFault(): after saving the fault record, automatically set the instrument
  status to Condemned via saveInstrument API, update local state, write a
  second audit entry (Event: 'Instrument condemned'), refresh the SN dropdown
  and dashboard. Shows a warning if auto-condemnation fails so staff can act.
- logUse(): add early guard blocking use logging for Condemned instruments.
- RISE_Presentation.pptx: updated deck for Quality Improvement judges —
  added Operational Improvement badge on cover, workflow before/after slide,
  and continuous improvement (feedback cycle) slide.

Co-Authored-By: Claude Sonnet 4.6 <noreply@anthropic.com>
Claude-Session: https://claude.ai/code/session_015w2gKQmRtYJ5wqtyRq9sAS
</commit_message>
<xml_diff>
--- a/RISE_Presentation.pptx
+++ b/RISE_Presentation.pptx
@@ -13,9 +13,10 @@
     <p:sldId id="261" r:id="rId7"/>
     <p:sldId id="262" r:id="rId8"/>
     <p:sldId id="263" r:id="rId9"/>
+    <p:sldId id="264" r:id="rId10"/>
   </p:sldIdLst>
   <p:notesMasterIdLst>
-    <p:notesMasterId r:id="rId10"/>
+    <p:notesMasterId r:id="rId11"/>
   </p:notesMasterIdLst>
   <p:sldSz cx="9144000" cy="5143500"/>
   <p:notesSz cx="5143500" cy="9144000"/>
@@ -1149,6 +1150,94 @@
             <a:fld id="{F7021451-1387-4CA6-816F-3879F97B5CBC}" type="slidenum">
               <a:rPr lang="en-US"/>
               <a:t>8</a:t>
+            </a:fld>
+            <a:endParaRPr lang="en-US"/>
+          </a:p>
+        </p:txBody>
+      </p:sp>
+    </p:spTree>
+    <p:extLst>
+      <p:ext uri="{BB962C8B-B14F-4D97-AF65-F5344CB8AC3E}">
+        <p14:creationId xmlns:p14="http://schemas.microsoft.com/office/powerpoint/2010/main" val="1024086991"/>
+      </p:ext>
+    </p:extLst>
+  </p:cSld>
+  <p:clrMapOvr>
+    <a:masterClrMapping/>
+  </p:clrMapOvr>
+</p:notes>
+</file>
+
+<file path=ppt/notesSlides/notesSlide9.xml><?xml version="1.0" encoding="utf-8"?>
+<p:notes xmlns:a="http://schemas.openxmlformats.org/drawingml/2006/main" xmlns:r="http://schemas.openxmlformats.org/officeDocument/2006/relationships" xmlns:p="http://schemas.openxmlformats.org/presentationml/2006/main">
+  <p:cSld>
+    <p:spTree>
+      <p:nvGrpSpPr>
+        <p:cNvPr id="1" name=""/>
+        <p:cNvGrpSpPr/>
+        <p:nvPr/>
+      </p:nvGrpSpPr>
+      <p:grpSpPr>
+        <a:xfrm>
+          <a:off x="0" y="0"/>
+          <a:ext cx="0" cy="0"/>
+          <a:chOff x="0" y="0"/>
+          <a:chExt cx="0" cy="0"/>
+        </a:xfrm>
+      </p:grpSpPr>
+      <p:sp>
+        <p:nvSpPr>
+          <p:cNvPr id="2" name="Slide Image Placeholder 1"/>
+          <p:cNvSpPr>
+            <a:spLocks noGrp="1" noRot="1" noChangeAspect="1"/>
+          </p:cNvSpPr>
+          <p:nvPr>
+            <p:ph type="sldImg"/>
+          </p:nvPr>
+        </p:nvSpPr>
+        <p:spPr/>
+      </p:sp>
+      <p:sp>
+        <p:nvSpPr>
+          <p:cNvPr id="3" name="Notes Placeholder 2"/>
+          <p:cNvSpPr>
+            <a:spLocks noGrp="1"/>
+          </p:cNvSpPr>
+          <p:nvPr>
+            <p:ph type="body" idx="1"/>
+          </p:nvPr>
+        </p:nvSpPr>
+        <p:spPr/>
+        <p:txBody>
+          <a:bodyPr/>
+          <a:lstStyle/>
+          <a:p>
+            <a:r>
+              <a:rPr lang="en-US" dirty="0"/>
+              <a:t/>
+            </a:r>
+            <a:endParaRPr lang="en-US" dirty="0"/>
+          </a:p>
+        </p:txBody>
+      </p:sp>
+      <p:sp>
+        <p:nvSpPr>
+          <p:cNvPr id="4" name="Slide Number Placeholder 3"/>
+          <p:cNvSpPr>
+            <a:spLocks noGrp="1"/>
+          </p:cNvSpPr>
+          <p:nvPr>
+            <p:ph type="sldNum" sz="quarter" idx="10"/>
+          </p:nvPr>
+        </p:nvSpPr>
+        <p:spPr/>
+        <p:txBody>
+          <a:bodyPr/>
+          <a:lstStyle/>
+          <a:p>
+            <a:fld id="{F7021451-1387-4CA6-816F-3879F97B5CBC}" type="slidenum">
+              <a:rPr lang="en-US"/>
+              <a:t>9</a:t>
             </a:fld>
             <a:endParaRPr lang="en-US"/>
           </a:p>
@@ -1675,13 +1764,79 @@
       </p:sp>
       <p:sp>
         <p:nvSpPr>
-          <p:cNvPr id="7" name="Text 5"/>
-          <p:cNvSpPr txBox="1"/>
-          <p:nvPr/>
-        </p:nvSpPr>
-        <p:spPr>
-          <a:xfrm>
-            <a:off x="502920" y="3639312"/>
+          <p:cNvPr id="7" name="Shape 5"/>
+          <p:cNvSpPr/>
+          <p:nvPr/>
+        </p:nvSpPr>
+        <p:spPr>
+          <a:xfrm>
+            <a:off x="502920" y="3401568"/>
+            <a:ext cx="2377440" cy="201168"/>
+          </a:xfrm>
+          <a:prstGeom prst="roundRect">
+            <a:avLst>
+              <a:gd name="adj" fmla="val 27273"/>
+            </a:avLst>
+          </a:prstGeom>
+          <a:solidFill>
+            <a:srgbClr val="00606E"/>
+          </a:solidFill>
+          <a:ln w="12700">
+            <a:solidFill>
+              <a:srgbClr val="00606E"/>
+            </a:solidFill>
+            <a:prstDash val="solid"/>
+          </a:ln>
+        </p:spPr>
+      </p:sp>
+      <p:sp>
+        <p:nvSpPr>
+          <p:cNvPr id="8" name="Text 6"/>
+          <p:cNvSpPr txBox="1"/>
+          <p:nvPr/>
+        </p:nvSpPr>
+        <p:spPr>
+          <a:xfrm>
+            <a:off x="502920" y="3401568"/>
+            <a:ext cx="2377440" cy="201168"/>
+          </a:xfrm>
+          <a:prstGeom prst="rect">
+            <a:avLst/>
+          </a:prstGeom>
+          <a:noFill/>
+          <a:ln/>
+        </p:spPr>
+        <p:txBody>
+          <a:bodyPr wrap="square" lIns="0" tIns="0" rIns="0" bIns="0" rtlCol="0" anchor="ctr"/>
+          <a:lstStyle/>
+          <a:p>
+            <a:pPr algn="ctr" indent="0" marL="0">
+              <a:buNone/>
+            </a:pPr>
+            <a:r>
+              <a:rPr lang="en-US" sz="750" b="1" spc="150" kern="0" dirty="0">
+                <a:solidFill>
+                  <a:srgbClr val="FFFFFF"/>
+                </a:solidFill>
+                <a:latin typeface="Calibri" pitchFamily="34" charset="0"/>
+                <a:ea typeface="Calibri" pitchFamily="34" charset="-122"/>
+                <a:cs typeface="Calibri" pitchFamily="34" charset="-120"/>
+              </a:rPr>
+              <a:t>OPERATIONAL IMPROVEMENT</a:t>
+            </a:r>
+            <a:endParaRPr lang="en-US" sz="750" dirty="0"/>
+          </a:p>
+        </p:txBody>
+      </p:sp>
+      <p:sp>
+        <p:nvSpPr>
+          <p:cNvPr id="9" name="Text 7"/>
+          <p:cNvSpPr txBox="1"/>
+          <p:nvPr/>
+        </p:nvSpPr>
+        <p:spPr>
+          <a:xfrm>
+            <a:off x="502920" y="3694176"/>
             <a:ext cx="5486400" cy="320040"/>
           </a:xfrm>
           <a:prstGeom prst="rect">
@@ -1714,7 +1869,7 @@
       </p:sp>
       <p:sp>
         <p:nvSpPr>
-          <p:cNvPr id="8" name="Text 6"/>
+          <p:cNvPr id="10" name="Text 8"/>
           <p:cNvSpPr txBox="1"/>
           <p:nvPr/>
         </p:nvSpPr>
@@ -2683,7 +2838,7 @@
                 <a:ea typeface="Calibri" pitchFamily="34" charset="-122"/>
                 <a:cs typeface="Calibri" pitchFamily="34" charset="-120"/>
               </a:rPr>
-              <a:t>RISE is a purpose-built digital system for the Robotics OT team at Changi General Hospital.</a:t>
+              <a:t>RISE is a purpose-built digital system for the Robotics OT team at Changi General Hospital — already live in the OT.</a:t>
             </a:r>
             <a:endParaRPr lang="en-US" sz="1300" dirty="0"/>
           </a:p>
@@ -2755,12 +2910,12 @@
         </p:nvSpPr>
         <p:spPr>
           <a:xfrm>
-            <a:off x="5486400" y="1188720"/>
-            <a:ext cx="3291840" cy="1051560"/>
+            <a:off x="5486400" y="1115568"/>
+            <a:ext cx="3246120" cy="1170432"/>
           </a:xfrm>
           <a:prstGeom prst="roundRect">
             <a:avLst>
-              <a:gd name="adj" fmla="val 6957"/>
+              <a:gd name="adj" fmla="val 6250"/>
             </a:avLst>
           </a:prstGeom>
           <a:solidFill>
@@ -2782,8 +2937,8 @@
         </p:nvSpPr>
         <p:spPr>
           <a:xfrm>
-            <a:off x="5623560" y="1261872"/>
-            <a:ext cx="1097280" cy="640080"/>
+            <a:off x="5596128" y="1207008"/>
+            <a:ext cx="1188720" cy="777240"/>
           </a:xfrm>
           <a:prstGeom prst="rect">
             <a:avLst/>
@@ -2799,7 +2954,7 @@
               <a:buNone/>
             </a:pPr>
             <a:r>
-              <a:rPr lang="en-US" sz="3800" b="1" dirty="0">
+              <a:rPr lang="en-US" sz="3200" b="1" dirty="0">
                 <a:solidFill>
                   <a:srgbClr val="00606E"/>
                 </a:solidFill>
@@ -2809,7 +2964,7 @@
               </a:rPr>
               <a:t>4</a:t>
             </a:r>
-            <a:endParaRPr lang="en-US" sz="3800" dirty="0"/>
+            <a:endParaRPr lang="en-US" sz="3200" dirty="0"/>
           </a:p>
         </p:txBody>
       </p:sp>
@@ -2821,8 +2976,8 @@
         </p:nvSpPr>
         <p:spPr>
           <a:xfrm>
-            <a:off x="5623560" y="1874520"/>
-            <a:ext cx="2926080" cy="256032"/>
+            <a:off x="6876288" y="1207008"/>
+            <a:ext cx="1737360" cy="347472"/>
           </a:xfrm>
           <a:prstGeom prst="rect">
             <a:avLst/>
@@ -2838,7 +2993,7 @@
               <a:buNone/>
             </a:pPr>
             <a:r>
-              <a:rPr lang="en-US" sz="1000" b="1" dirty="0">
+              <a:rPr lang="en-US" sz="1050" b="1" dirty="0">
                 <a:solidFill>
                   <a:srgbClr val="002D4A"/>
                 </a:solidFill>
@@ -2848,46 +3003,46 @@
               </a:rPr>
               <a:t>Core modules</a:t>
             </a:r>
+            <a:endParaRPr lang="en-US" sz="1050" dirty="0"/>
+          </a:p>
+        </p:txBody>
+      </p:sp>
+      <p:sp>
+        <p:nvSpPr>
+          <p:cNvPr id="8" name="Text 6"/>
+          <p:cNvSpPr txBox="1"/>
+          <p:nvPr/>
+        </p:nvSpPr>
+        <p:spPr>
+          <a:xfrm>
+            <a:off x="6876288" y="1572768"/>
+            <a:ext cx="1737360" cy="594360"/>
+          </a:xfrm>
+          <a:prstGeom prst="rect">
+            <a:avLst/>
+          </a:prstGeom>
+          <a:noFill/>
+          <a:ln/>
+        </p:spPr>
+        <p:txBody>
+          <a:bodyPr wrap="square" lIns="0" tIns="0" rIns="0" bIns="0" rtlCol="0" anchor="ctr"/>
+          <a:lstStyle/>
+          <a:p>
+            <a:pPr indent="0" marL="0">
+              <a:buNone/>
+            </a:pPr>
+            <a:r>
+              <a:rPr lang="en-US" sz="1000" dirty="0">
+                <a:solidFill>
+                  <a:srgbClr val="4A5568"/>
+                </a:solidFill>
+                <a:latin typeface="Calibri" pitchFamily="34" charset="0"/>
+                <a:ea typeface="Calibri" pitchFamily="34" charset="-122"/>
+                <a:cs typeface="Calibri" pitchFamily="34" charset="-120"/>
+              </a:rPr>
+              <a:t>Instruments · Consumables · Faults · Audit</a:t>
+            </a:r>
             <a:endParaRPr lang="en-US" sz="1000" dirty="0"/>
-          </a:p>
-        </p:txBody>
-      </p:sp>
-      <p:sp>
-        <p:nvSpPr>
-          <p:cNvPr id="8" name="Text 6"/>
-          <p:cNvSpPr txBox="1"/>
-          <p:nvPr/>
-        </p:nvSpPr>
-        <p:spPr>
-          <a:xfrm>
-            <a:off x="6858000" y="1353312"/>
-            <a:ext cx="2697480" cy="640080"/>
-          </a:xfrm>
-          <a:prstGeom prst="rect">
-            <a:avLst/>
-          </a:prstGeom>
-          <a:noFill/>
-          <a:ln/>
-        </p:spPr>
-        <p:txBody>
-          <a:bodyPr wrap="square" lIns="0" tIns="0" rIns="0" bIns="0" rtlCol="0" anchor="ctr"/>
-          <a:lstStyle/>
-          <a:p>
-            <a:pPr indent="0" marL="0">
-              <a:buNone/>
-            </a:pPr>
-            <a:r>
-              <a:rPr lang="en-US" sz="1050" dirty="0">
-                <a:solidFill>
-                  <a:srgbClr val="4A5568"/>
-                </a:solidFill>
-                <a:latin typeface="Calibri" pitchFamily="34" charset="0"/>
-                <a:ea typeface="Calibri" pitchFamily="34" charset="-122"/>
-                <a:cs typeface="Calibri" pitchFamily="34" charset="-120"/>
-              </a:rPr>
-              <a:t>Instruments · Consumables · Faults · Audit</a:t>
-            </a:r>
-            <a:endParaRPr lang="en-US" sz="1050" dirty="0"/>
           </a:p>
         </p:txBody>
       </p:sp>
@@ -2899,12 +3054,12 @@
         </p:nvSpPr>
         <p:spPr>
           <a:xfrm>
-            <a:off x="5486400" y="2423160"/>
-            <a:ext cx="3291840" cy="1051560"/>
+            <a:off x="5486400" y="2414016"/>
+            <a:ext cx="3246120" cy="1170432"/>
           </a:xfrm>
           <a:prstGeom prst="roundRect">
             <a:avLst>
-              <a:gd name="adj" fmla="val 6957"/>
+              <a:gd name="adj" fmla="val 6250"/>
             </a:avLst>
           </a:prstGeom>
           <a:solidFill>
@@ -2926,8 +3081,8 @@
         </p:nvSpPr>
         <p:spPr>
           <a:xfrm>
-            <a:off x="5623560" y="2496312"/>
-            <a:ext cx="1097280" cy="640080"/>
+            <a:off x="5596128" y="2505456"/>
+            <a:ext cx="1188720" cy="777240"/>
           </a:xfrm>
           <a:prstGeom prst="rect">
             <a:avLst/>
@@ -2943,7 +3098,7 @@
               <a:buNone/>
             </a:pPr>
             <a:r>
-              <a:rPr lang="en-US" sz="3800" b="1" dirty="0">
+              <a:rPr lang="en-US" sz="3200" b="1" dirty="0">
                 <a:solidFill>
                   <a:srgbClr val="00606E"/>
                 </a:solidFill>
@@ -2953,7 +3108,7 @@
               </a:rPr>
               <a:t>100%</a:t>
             </a:r>
-            <a:endParaRPr lang="en-US" sz="3800" dirty="0"/>
+            <a:endParaRPr lang="en-US" sz="3200" dirty="0"/>
           </a:p>
         </p:txBody>
       </p:sp>
@@ -2965,8 +3120,8 @@
         </p:nvSpPr>
         <p:spPr>
           <a:xfrm>
-            <a:off x="5623560" y="3108960"/>
-            <a:ext cx="2926080" cy="256032"/>
+            <a:off x="6876288" y="2505456"/>
+            <a:ext cx="1737360" cy="347472"/>
           </a:xfrm>
           <a:prstGeom prst="rect">
             <a:avLst/>
@@ -2982,7 +3137,7 @@
               <a:buNone/>
             </a:pPr>
             <a:r>
-              <a:rPr lang="en-US" sz="1000" b="1" dirty="0">
+              <a:rPr lang="en-US" sz="1050" b="1" dirty="0">
                 <a:solidFill>
                   <a:srgbClr val="002D4A"/>
                 </a:solidFill>
@@ -2992,46 +3147,46 @@
               </a:rPr>
               <a:t>Audit coverage</a:t>
             </a:r>
+            <a:endParaRPr lang="en-US" sz="1050" dirty="0"/>
+          </a:p>
+        </p:txBody>
+      </p:sp>
+      <p:sp>
+        <p:nvSpPr>
+          <p:cNvPr id="12" name="Text 10"/>
+          <p:cNvSpPr txBox="1"/>
+          <p:nvPr/>
+        </p:nvSpPr>
+        <p:spPr>
+          <a:xfrm>
+            <a:off x="6876288" y="2871216"/>
+            <a:ext cx="1737360" cy="594360"/>
+          </a:xfrm>
+          <a:prstGeom prst="rect">
+            <a:avLst/>
+          </a:prstGeom>
+          <a:noFill/>
+          <a:ln/>
+        </p:spPr>
+        <p:txBody>
+          <a:bodyPr wrap="square" lIns="0" tIns="0" rIns="0" bIns="0" rtlCol="0" anchor="ctr"/>
+          <a:lstStyle/>
+          <a:p>
+            <a:pPr indent="0" marL="0">
+              <a:buNone/>
+            </a:pPr>
+            <a:r>
+              <a:rPr lang="en-US" sz="1000" dirty="0">
+                <a:solidFill>
+                  <a:srgbClr val="4A5568"/>
+                </a:solidFill>
+                <a:latin typeface="Calibri" pitchFamily="34" charset="0"/>
+                <a:ea typeface="Calibri" pitchFamily="34" charset="-122"/>
+                <a:cs typeface="Calibri" pitchFamily="34" charset="-120"/>
+              </a:rPr>
+              <a:t>Every write triggers an audit trail entry</a:t>
+            </a:r>
             <a:endParaRPr lang="en-US" sz="1000" dirty="0"/>
-          </a:p>
-        </p:txBody>
-      </p:sp>
-      <p:sp>
-        <p:nvSpPr>
-          <p:cNvPr id="12" name="Text 10"/>
-          <p:cNvSpPr txBox="1"/>
-          <p:nvPr/>
-        </p:nvSpPr>
-        <p:spPr>
-          <a:xfrm>
-            <a:off x="6858000" y="2587752"/>
-            <a:ext cx="2697480" cy="640080"/>
-          </a:xfrm>
-          <a:prstGeom prst="rect">
-            <a:avLst/>
-          </a:prstGeom>
-          <a:noFill/>
-          <a:ln/>
-        </p:spPr>
-        <p:txBody>
-          <a:bodyPr wrap="square" lIns="0" tIns="0" rIns="0" bIns="0" rtlCol="0" anchor="ctr"/>
-          <a:lstStyle/>
-          <a:p>
-            <a:pPr indent="0" marL="0">
-              <a:buNone/>
-            </a:pPr>
-            <a:r>
-              <a:rPr lang="en-US" sz="1050" dirty="0">
-                <a:solidFill>
-                  <a:srgbClr val="4A5568"/>
-                </a:solidFill>
-                <a:latin typeface="Calibri" pitchFamily="34" charset="0"/>
-                <a:ea typeface="Calibri" pitchFamily="34" charset="-122"/>
-                <a:cs typeface="Calibri" pitchFamily="34" charset="-120"/>
-              </a:rPr>
-              <a:t>Every write triggers an audit trail entry</a:t>
-            </a:r>
-            <a:endParaRPr lang="en-US" sz="1050" dirty="0"/>
           </a:p>
         </p:txBody>
       </p:sp>
@@ -3043,12 +3198,12 @@
         </p:nvSpPr>
         <p:spPr>
           <a:xfrm>
-            <a:off x="5486400" y="3657600"/>
-            <a:ext cx="3291840" cy="1051560"/>
+            <a:off x="5486400" y="3712464"/>
+            <a:ext cx="3246120" cy="1170432"/>
           </a:xfrm>
           <a:prstGeom prst="roundRect">
             <a:avLst>
-              <a:gd name="adj" fmla="val 6957"/>
+              <a:gd name="adj" fmla="val 6250"/>
             </a:avLst>
           </a:prstGeom>
           <a:solidFill>
@@ -3070,8 +3225,8 @@
         </p:nvSpPr>
         <p:spPr>
           <a:xfrm>
-            <a:off x="5623560" y="3730752"/>
-            <a:ext cx="1097280" cy="640080"/>
+            <a:off x="5596128" y="3803904"/>
+            <a:ext cx="1188720" cy="777240"/>
           </a:xfrm>
           <a:prstGeom prst="rect">
             <a:avLst/>
@@ -3087,7 +3242,7 @@
               <a:buNone/>
             </a:pPr>
             <a:r>
-              <a:rPr lang="en-US" sz="3800" b="1" dirty="0">
+              <a:rPr lang="en-US" sz="3200" b="1" dirty="0">
                 <a:solidFill>
                   <a:srgbClr val="00606E"/>
                 </a:solidFill>
@@ -3097,7 +3252,7 @@
               </a:rPr>
               <a:t>0</a:t>
             </a:r>
-            <a:endParaRPr lang="en-US" sz="3800" dirty="0"/>
+            <a:endParaRPr lang="en-US" sz="3200" dirty="0"/>
           </a:p>
         </p:txBody>
       </p:sp>
@@ -3109,8 +3264,8 @@
         </p:nvSpPr>
         <p:spPr>
           <a:xfrm>
-            <a:off x="5623560" y="4343400"/>
-            <a:ext cx="2926080" cy="256032"/>
+            <a:off x="6876288" y="3803904"/>
+            <a:ext cx="1737360" cy="347472"/>
           </a:xfrm>
           <a:prstGeom prst="rect">
             <a:avLst/>
@@ -3126,7 +3281,7 @@
               <a:buNone/>
             </a:pPr>
             <a:r>
-              <a:rPr lang="en-US" sz="1000" b="1" dirty="0">
+              <a:rPr lang="en-US" sz="1050" b="1" dirty="0">
                 <a:solidFill>
                   <a:srgbClr val="002D4A"/>
                 </a:solidFill>
@@ -3136,46 +3291,46 @@
               </a:rPr>
               <a:t>Silent failures</a:t>
             </a:r>
+            <a:endParaRPr lang="en-US" sz="1050" dirty="0"/>
+          </a:p>
+        </p:txBody>
+      </p:sp>
+      <p:sp>
+        <p:nvSpPr>
+          <p:cNvPr id="16" name="Text 14"/>
+          <p:cNvSpPr txBox="1"/>
+          <p:nvPr/>
+        </p:nvSpPr>
+        <p:spPr>
+          <a:xfrm>
+            <a:off x="6876288" y="4169664"/>
+            <a:ext cx="1737360" cy="594360"/>
+          </a:xfrm>
+          <a:prstGeom prst="rect">
+            <a:avLst/>
+          </a:prstGeom>
+          <a:noFill/>
+          <a:ln/>
+        </p:spPr>
+        <p:txBody>
+          <a:bodyPr wrap="square" lIns="0" tIns="0" rIns="0" bIns="0" rtlCol="0" anchor="ctr"/>
+          <a:lstStyle/>
+          <a:p>
+            <a:pPr indent="0" marL="0">
+              <a:buNone/>
+            </a:pPr>
+            <a:r>
+              <a:rPr lang="en-US" sz="1000" dirty="0">
+                <a:solidFill>
+                  <a:srgbClr val="4A5568"/>
+                </a:solidFill>
+                <a:latin typeface="Calibri" pitchFamily="34" charset="0"/>
+                <a:ea typeface="Calibri" pitchFamily="34" charset="-122"/>
+                <a:cs typeface="Calibri" pitchFamily="34" charset="-120"/>
+              </a:rPr>
+              <a:t>Staff are alerted if any audit write fails</a:t>
+            </a:r>
             <a:endParaRPr lang="en-US" sz="1000" dirty="0"/>
-          </a:p>
-        </p:txBody>
-      </p:sp>
-      <p:sp>
-        <p:nvSpPr>
-          <p:cNvPr id="16" name="Text 14"/>
-          <p:cNvSpPr txBox="1"/>
-          <p:nvPr/>
-        </p:nvSpPr>
-        <p:spPr>
-          <a:xfrm>
-            <a:off x="6858000" y="3822192"/>
-            <a:ext cx="2697480" cy="640080"/>
-          </a:xfrm>
-          <a:prstGeom prst="rect">
-            <a:avLst/>
-          </a:prstGeom>
-          <a:noFill/>
-          <a:ln/>
-        </p:spPr>
-        <p:txBody>
-          <a:bodyPr wrap="square" lIns="0" tIns="0" rIns="0" bIns="0" rtlCol="0" anchor="ctr"/>
-          <a:lstStyle/>
-          <a:p>
-            <a:pPr indent="0" marL="0">
-              <a:buNone/>
-            </a:pPr>
-            <a:r>
-              <a:rPr lang="en-US" sz="1050" dirty="0">
-                <a:solidFill>
-                  <a:srgbClr val="4A5568"/>
-                </a:solidFill>
-                <a:latin typeface="Calibri" pitchFamily="34" charset="0"/>
-                <a:ea typeface="Calibri" pitchFamily="34" charset="-122"/>
-                <a:cs typeface="Calibri" pitchFamily="34" charset="-120"/>
-              </a:rPr>
-              <a:t>Staff are alerted if any audit write fails</a:t>
-            </a:r>
-            <a:endParaRPr lang="en-US" sz="1050" dirty="0"/>
           </a:p>
         </p:txBody>
       </p:sp>
@@ -3297,12 +3452,12 @@
         </p:nvSpPr>
         <p:spPr>
           <a:xfrm>
-            <a:off x="292608" y="1280160"/>
-            <a:ext cx="1682496" cy="3246120"/>
+            <a:off x="274320" y="1280160"/>
+            <a:ext cx="1645920" cy="3246120"/>
           </a:xfrm>
           <a:prstGeom prst="roundRect">
             <a:avLst>
-              <a:gd name="adj" fmla="val 4348"/>
+              <a:gd name="adj" fmla="val 4444"/>
             </a:avLst>
           </a:prstGeom>
           <a:solidFill>
@@ -3324,7 +3479,7 @@
         </p:nvSpPr>
         <p:spPr>
           <a:xfrm>
-            <a:off x="832104" y="1572768"/>
+            <a:off x="795528" y="1572768"/>
             <a:ext cx="603504" cy="603504"/>
           </a:xfrm>
           <a:prstGeom prst="ellipse">
@@ -3349,7 +3504,7 @@
         </p:nvSpPr>
         <p:spPr>
           <a:xfrm>
-            <a:off x="832104" y="1572768"/>
+            <a:off x="795528" y="1572768"/>
             <a:ext cx="603504" cy="603504"/>
           </a:xfrm>
           <a:prstGeom prst="rect">
@@ -3388,8 +3543,8 @@
         </p:nvSpPr>
         <p:spPr>
           <a:xfrm>
-            <a:off x="365760" y="2331720"/>
-            <a:ext cx="1536192" cy="411480"/>
+            <a:off x="347472" y="2331720"/>
+            <a:ext cx="1499616" cy="411480"/>
           </a:xfrm>
           <a:prstGeom prst="rect">
             <a:avLst/>
@@ -3427,8 +3582,8 @@
         </p:nvSpPr>
         <p:spPr>
           <a:xfrm>
-            <a:off x="384048" y="2816352"/>
-            <a:ext cx="1499616" cy="1508760"/>
+            <a:off x="365760" y="2816352"/>
+            <a:ext cx="1463040" cy="1508760"/>
           </a:xfrm>
           <a:prstGeom prst="rect">
             <a:avLst/>
@@ -3466,12 +3621,12 @@
         </p:nvSpPr>
         <p:spPr>
           <a:xfrm>
-            <a:off x="2066544" y="1280160"/>
-            <a:ext cx="1682496" cy="3246120"/>
+            <a:off x="2011680" y="1280160"/>
+            <a:ext cx="1645920" cy="3246120"/>
           </a:xfrm>
           <a:prstGeom prst="roundRect">
             <a:avLst>
-              <a:gd name="adj" fmla="val 4348"/>
+              <a:gd name="adj" fmla="val 4444"/>
             </a:avLst>
           </a:prstGeom>
           <a:solidFill>
@@ -3493,7 +3648,7 @@
         </p:nvSpPr>
         <p:spPr>
           <a:xfrm>
-            <a:off x="2606040" y="1572768"/>
+            <a:off x="2532888" y="1572768"/>
             <a:ext cx="603504" cy="603504"/>
           </a:xfrm>
           <a:prstGeom prst="ellipse">
@@ -3518,7 +3673,7 @@
         </p:nvSpPr>
         <p:spPr>
           <a:xfrm>
-            <a:off x="2606040" y="1572768"/>
+            <a:off x="2532888" y="1572768"/>
             <a:ext cx="603504" cy="603504"/>
           </a:xfrm>
           <a:prstGeom prst="rect">
@@ -3557,8 +3712,8 @@
         </p:nvSpPr>
         <p:spPr>
           <a:xfrm>
-            <a:off x="2139696" y="2331720"/>
-            <a:ext cx="1536192" cy="411480"/>
+            <a:off x="2084832" y="2331720"/>
+            <a:ext cx="1499616" cy="411480"/>
           </a:xfrm>
           <a:prstGeom prst="rect">
             <a:avLst/>
@@ -3596,8 +3751,8 @@
         </p:nvSpPr>
         <p:spPr>
           <a:xfrm>
-            <a:off x="2157984" y="2816352"/>
-            <a:ext cx="1499616" cy="1508760"/>
+            <a:off x="2103120" y="2816352"/>
+            <a:ext cx="1463040" cy="1508760"/>
           </a:xfrm>
           <a:prstGeom prst="rect">
             <a:avLst/>
@@ -3635,12 +3790,12 @@
         </p:nvSpPr>
         <p:spPr>
           <a:xfrm>
-            <a:off x="3840480" y="1280160"/>
-            <a:ext cx="1682496" cy="3246120"/>
+            <a:off x="3749040" y="1280160"/>
+            <a:ext cx="1645920" cy="3246120"/>
           </a:xfrm>
           <a:prstGeom prst="roundRect">
             <a:avLst>
-              <a:gd name="adj" fmla="val 4348"/>
+              <a:gd name="adj" fmla="val 4444"/>
             </a:avLst>
           </a:prstGeom>
           <a:solidFill>
@@ -3662,7 +3817,7 @@
         </p:nvSpPr>
         <p:spPr>
           <a:xfrm>
-            <a:off x="4379976" y="1572768"/>
+            <a:off x="4270248" y="1572768"/>
             <a:ext cx="603504" cy="603504"/>
           </a:xfrm>
           <a:prstGeom prst="ellipse">
@@ -3687,7 +3842,7 @@
         </p:nvSpPr>
         <p:spPr>
           <a:xfrm>
-            <a:off x="4379976" y="1572768"/>
+            <a:off x="4270248" y="1572768"/>
             <a:ext cx="603504" cy="603504"/>
           </a:xfrm>
           <a:prstGeom prst="rect">
@@ -3726,8 +3881,8 @@
         </p:nvSpPr>
         <p:spPr>
           <a:xfrm>
-            <a:off x="3913632" y="2331720"/>
-            <a:ext cx="1536192" cy="411480"/>
+            <a:off x="3822192" y="2331720"/>
+            <a:ext cx="1499616" cy="411480"/>
           </a:xfrm>
           <a:prstGeom prst="rect">
             <a:avLst/>
@@ -3765,8 +3920,8 @@
         </p:nvSpPr>
         <p:spPr>
           <a:xfrm>
-            <a:off x="3931920" y="2816352"/>
-            <a:ext cx="1499616" cy="1508760"/>
+            <a:off x="3840480" y="2816352"/>
+            <a:ext cx="1463040" cy="1508760"/>
           </a:xfrm>
           <a:prstGeom prst="rect">
             <a:avLst/>
@@ -3804,12 +3959,12 @@
         </p:nvSpPr>
         <p:spPr>
           <a:xfrm>
-            <a:off x="5614416" y="1280160"/>
-            <a:ext cx="1682496" cy="3246120"/>
+            <a:off x="5486400" y="1280160"/>
+            <a:ext cx="1645920" cy="3246120"/>
           </a:xfrm>
           <a:prstGeom prst="roundRect">
             <a:avLst>
-              <a:gd name="adj" fmla="val 4348"/>
+              <a:gd name="adj" fmla="val 4444"/>
             </a:avLst>
           </a:prstGeom>
           <a:solidFill>
@@ -3831,7 +3986,7 @@
         </p:nvSpPr>
         <p:spPr>
           <a:xfrm>
-            <a:off x="6153912" y="1572768"/>
+            <a:off x="6007608" y="1572768"/>
             <a:ext cx="603504" cy="603504"/>
           </a:xfrm>
           <a:prstGeom prst="ellipse">
@@ -3856,7 +4011,7 @@
         </p:nvSpPr>
         <p:spPr>
           <a:xfrm>
-            <a:off x="6153912" y="1572768"/>
+            <a:off x="6007608" y="1572768"/>
             <a:ext cx="603504" cy="603504"/>
           </a:xfrm>
           <a:prstGeom prst="rect">
@@ -3895,8 +4050,8 @@
         </p:nvSpPr>
         <p:spPr>
           <a:xfrm>
-            <a:off x="5687568" y="2331720"/>
-            <a:ext cx="1536192" cy="411480"/>
+            <a:off x="5559552" y="2331720"/>
+            <a:ext cx="1499616" cy="411480"/>
           </a:xfrm>
           <a:prstGeom prst="rect">
             <a:avLst/>
@@ -3934,8 +4089,8 @@
         </p:nvSpPr>
         <p:spPr>
           <a:xfrm>
-            <a:off x="5705856" y="2816352"/>
-            <a:ext cx="1499616" cy="1508760"/>
+            <a:off x="5577840" y="2816352"/>
+            <a:ext cx="1463040" cy="1508760"/>
           </a:xfrm>
           <a:prstGeom prst="rect">
             <a:avLst/>
@@ -3973,12 +4128,12 @@
         </p:nvSpPr>
         <p:spPr>
           <a:xfrm>
-            <a:off x="7388352" y="1280160"/>
-            <a:ext cx="1682496" cy="3246120"/>
+            <a:off x="7223760" y="1280160"/>
+            <a:ext cx="1645920" cy="3246120"/>
           </a:xfrm>
           <a:prstGeom prst="roundRect">
             <a:avLst>
-              <a:gd name="adj" fmla="val 4348"/>
+              <a:gd name="adj" fmla="val 4444"/>
             </a:avLst>
           </a:prstGeom>
           <a:solidFill>
@@ -4000,7 +4155,7 @@
         </p:nvSpPr>
         <p:spPr>
           <a:xfrm>
-            <a:off x="7927848" y="1572768"/>
+            <a:off x="7744968" y="1572768"/>
             <a:ext cx="603504" cy="603504"/>
           </a:xfrm>
           <a:prstGeom prst="ellipse">
@@ -4025,7 +4180,7 @@
         </p:nvSpPr>
         <p:spPr>
           <a:xfrm>
-            <a:off x="7927848" y="1572768"/>
+            <a:off x="7744968" y="1572768"/>
             <a:ext cx="603504" cy="603504"/>
           </a:xfrm>
           <a:prstGeom prst="rect">
@@ -4064,8 +4219,8 @@
         </p:nvSpPr>
         <p:spPr>
           <a:xfrm>
-            <a:off x="7461504" y="2331720"/>
-            <a:ext cx="1536192" cy="411480"/>
+            <a:off x="7296912" y="2331720"/>
+            <a:ext cx="1499616" cy="411480"/>
           </a:xfrm>
           <a:prstGeom prst="rect">
             <a:avLst/>
@@ -4103,8 +4258,8 @@
         </p:nvSpPr>
         <p:spPr>
           <a:xfrm>
-            <a:off x="7479792" y="2816352"/>
-            <a:ext cx="1499616" cy="1508760"/>
+            <a:off x="7315200" y="2816352"/>
+            <a:ext cx="1463040" cy="1508760"/>
           </a:xfrm>
           <a:prstGeom prst="rect">
             <a:avLst/>
@@ -5221,7 +5376,7 @@
                 <a:ea typeface="Calibri" pitchFamily="34" charset="-122"/>
                 <a:cs typeface="Calibri" pitchFamily="34" charset="-120"/>
               </a:rPr>
-              <a:t>THE ROADMAP</a:t>
+              <a:t>OPERATIONAL IMPROVEMENT</a:t>
             </a:r>
             <a:endParaRPr lang="en-US" sz="850" dirty="0"/>
           </a:p>
@@ -5260,7 +5415,7 @@
                 <a:ea typeface="Calibri" pitchFamily="34" charset="-122"/>
                 <a:cs typeface="Calibri" pitchFamily="34" charset="-120"/>
               </a:rPr>
-              <a:t>From Web App to Microsoft PowerApps</a:t>
+              <a:t>How RISE Changes the Workflow</a:t>
             </a:r>
             <a:endParaRPr lang="en-US" sz="2800" dirty="0"/>
           </a:p>
@@ -5302,7 +5457,7 @@
         <p:spPr>
           <a:xfrm>
             <a:off x="530352" y="1371600"/>
-            <a:ext cx="1371600" cy="329184"/>
+            <a:ext cx="2743200" cy="329184"/>
           </a:xfrm>
           <a:prstGeom prst="rect">
             <a:avLst/>
@@ -5326,7 +5481,7 @@
                 <a:ea typeface="Calibri" pitchFamily="34" charset="-122"/>
                 <a:cs typeface="Calibri" pitchFamily="34" charset="-120"/>
               </a:rPr>
-              <a:t>NOW</a:t>
+              <a:t>BEFORE RISE</a:t>
             </a:r>
             <a:endParaRPr lang="en-US" sz="1100" dirty="0"/>
           </a:p>
@@ -5365,7 +5520,7 @@
                 <a:ea typeface="Calibri" pitchFamily="34" charset="-122"/>
                 <a:cs typeface="Calibri" pitchFamily="34" charset="-120"/>
               </a:rPr>
-              <a:t>•  Custom web app (HTML + JavaScript)</a:t>
+              <a:t>•  Paper logbook entry for each instrument use</a:t>
             </a:r>
             <a:endParaRPr lang="en-US" sz="1150" dirty="0"/>
           </a:p>
@@ -5404,7 +5559,7 @@
                 <a:ea typeface="Calibri" pitchFamily="34" charset="-122"/>
                 <a:cs typeface="Calibri" pitchFamily="34" charset="-120"/>
               </a:rPr>
-              <a:t>•  Google Apps Script REST backend</a:t>
+              <a:t>•  Manual search through binders for records</a:t>
             </a:r>
             <a:endParaRPr lang="en-US" sz="1150" dirty="0"/>
           </a:p>
@@ -5443,7 +5598,7 @@
                 <a:ea typeface="Calibri" pitchFamily="34" charset="-122"/>
                 <a:cs typeface="Calibri" pitchFamily="34" charset="-120"/>
               </a:rPr>
-              <a:t>•  Google Sheets as the database</a:t>
+              <a:t>•  Faults noted informally — sometimes missed</a:t>
             </a:r>
             <a:endParaRPr lang="en-US" sz="1150" dirty="0"/>
           </a:p>
@@ -5482,7 +5637,7 @@
                 <a:ea typeface="Calibri" pitchFamily="34" charset="-122"/>
                 <a:cs typeface="Calibri" pitchFamily="34" charset="-120"/>
               </a:rPr>
-              <a:t>•  GitHub Pages hosting</a:t>
+              <a:t>•  Audit requires manual record reconstruction</a:t>
             </a:r>
             <a:endParaRPr lang="en-US" sz="1150" dirty="0"/>
           </a:p>
@@ -5496,47 +5651,8 @@
         </p:nvSpPr>
         <p:spPr>
           <a:xfrm>
-            <a:off x="548640" y="3776472"/>
-            <a:ext cx="3474720" cy="402336"/>
-          </a:xfrm>
-          <a:prstGeom prst="rect">
-            <a:avLst/>
-          </a:prstGeom>
-          <a:noFill/>
-          <a:ln/>
-        </p:spPr>
-        <p:txBody>
-          <a:bodyPr wrap="square" lIns="0" tIns="0" rIns="0" bIns="0" rtlCol="0" anchor="ctr"/>
-          <a:lstStyle/>
-          <a:p>
-            <a:pPr indent="0" marL="0">
-              <a:buNone/>
-            </a:pPr>
-            <a:r>
-              <a:rPr lang="en-US" sz="1150" dirty="0">
-                <a:solidFill>
-                  <a:srgbClr val="1C2230"/>
-                </a:solidFill>
-                <a:latin typeface="Calibri" pitchFamily="34" charset="0"/>
-                <a:ea typeface="Calibri" pitchFamily="34" charset="-122"/>
-                <a:cs typeface="Calibri" pitchFamily="34" charset="-120"/>
-              </a:rPr>
-              <a:t>•  Browser-only access</a:t>
-            </a:r>
-            <a:endParaRPr lang="en-US" sz="1150" dirty="0"/>
-          </a:p>
-        </p:txBody>
-      </p:sp>
-      <p:sp>
-        <p:nvSpPr>
-          <p:cNvPr id="11" name="Text 9"/>
-          <p:cNvSpPr txBox="1"/>
-          <p:nvPr/>
-        </p:nvSpPr>
-        <p:spPr>
-          <a:xfrm>
-            <a:off x="4315968" y="2606040"/>
-            <a:ext cx="603504" cy="640080"/>
+            <a:off x="4315968" y="2743200"/>
+            <a:ext cx="603504" cy="594360"/>
           </a:xfrm>
           <a:prstGeom prst="rect">
             <a:avLst/>
@@ -5568,7 +5684,7 @@
       </p:sp>
       <p:sp>
         <p:nvSpPr>
-          <p:cNvPr id="12" name="Shape 10"/>
+          <p:cNvPr id="11" name="Shape 9"/>
           <p:cNvSpPr/>
           <p:nvPr/>
         </p:nvSpPr>
@@ -5595,46 +5711,46 @@
       </p:sp>
       <p:sp>
         <p:nvSpPr>
+          <p:cNvPr id="12" name="Text 10"/>
+          <p:cNvSpPr txBox="1"/>
+          <p:nvPr/>
+        </p:nvSpPr>
+        <p:spPr>
+          <a:xfrm>
+            <a:off x="5138928" y="1371600"/>
+            <a:ext cx="2743200" cy="329184"/>
+          </a:xfrm>
+          <a:prstGeom prst="rect">
+            <a:avLst/>
+          </a:prstGeom>
+          <a:noFill/>
+          <a:ln/>
+        </p:spPr>
+        <p:txBody>
+          <a:bodyPr wrap="square" lIns="0" tIns="0" rIns="0" bIns="0" rtlCol="0" anchor="ctr"/>
+          <a:lstStyle/>
+          <a:p>
+            <a:pPr indent="0" marL="0">
+              <a:buNone/>
+            </a:pPr>
+            <a:r>
+              <a:rPr lang="en-US" sz="1100" b="1" dirty="0">
+                <a:solidFill>
+                  <a:srgbClr val="00606E"/>
+                </a:solidFill>
+                <a:latin typeface="Calibri" pitchFamily="34" charset="0"/>
+                <a:ea typeface="Calibri" pitchFamily="34" charset="-122"/>
+                <a:cs typeface="Calibri" pitchFamily="34" charset="-120"/>
+              </a:rPr>
+              <a:t>WITH RISE</a:t>
+            </a:r>
+            <a:endParaRPr lang="en-US" sz="1100" dirty="0"/>
+          </a:p>
+        </p:txBody>
+      </p:sp>
+      <p:sp>
+        <p:nvSpPr>
           <p:cNvPr id="13" name="Text 11"/>
-          <p:cNvSpPr txBox="1"/>
-          <p:nvPr/>
-        </p:nvSpPr>
-        <p:spPr>
-          <a:xfrm>
-            <a:off x="5138928" y="1371600"/>
-            <a:ext cx="1371600" cy="329184"/>
-          </a:xfrm>
-          <a:prstGeom prst="rect">
-            <a:avLst/>
-          </a:prstGeom>
-          <a:noFill/>
-          <a:ln/>
-        </p:spPr>
-        <p:txBody>
-          <a:bodyPr wrap="square" lIns="0" tIns="0" rIns="0" bIns="0" rtlCol="0" anchor="ctr"/>
-          <a:lstStyle/>
-          <a:p>
-            <a:pPr indent="0" marL="0">
-              <a:buNone/>
-            </a:pPr>
-            <a:r>
-              <a:rPr lang="en-US" sz="1100" b="1" dirty="0">
-                <a:solidFill>
-                  <a:srgbClr val="00606E"/>
-                </a:solidFill>
-                <a:latin typeface="Calibri" pitchFamily="34" charset="0"/>
-                <a:ea typeface="Calibri" pitchFamily="34" charset="-122"/>
-                <a:cs typeface="Calibri" pitchFamily="34" charset="-120"/>
-              </a:rPr>
-              <a:t>NEXT</a:t>
-            </a:r>
-            <a:endParaRPr lang="en-US" sz="1100" dirty="0"/>
-          </a:p>
-        </p:txBody>
-      </p:sp>
-      <p:sp>
-        <p:nvSpPr>
-          <p:cNvPr id="14" name="Text 12"/>
           <p:cNvSpPr txBox="1"/>
           <p:nvPr/>
         </p:nvSpPr>
@@ -5665,7 +5781,7 @@
                 <a:ea typeface="Calibri" pitchFamily="34" charset="-122"/>
                 <a:cs typeface="Calibri" pitchFamily="34" charset="-120"/>
               </a:rPr>
-              <a:t>•  PowerApps Canvas App (mobile + desktop)</a:t>
+              <a:t>•  One tap — use logged instantly with timestamp</a:t>
             </a:r>
             <a:endParaRPr lang="en-US" sz="1150" dirty="0"/>
           </a:p>
@@ -5673,7 +5789,7 @@
       </p:sp>
       <p:sp>
         <p:nvSpPr>
-          <p:cNvPr id="15" name="Text 13"/>
+          <p:cNvPr id="14" name="Text 12"/>
           <p:cNvSpPr txBox="1"/>
           <p:nvPr/>
         </p:nvSpPr>
@@ -5704,7 +5820,7 @@
                 <a:ea typeface="Calibri" pitchFamily="34" charset="-122"/>
                 <a:cs typeface="Calibri" pitchFamily="34" charset="-120"/>
               </a:rPr>
-              <a:t>•  SharePoint Lists as the database</a:t>
+              <a:t>•  Instant search — full history in seconds</a:t>
             </a:r>
             <a:endParaRPr lang="en-US" sz="1150" dirty="0"/>
           </a:p>
@@ -5712,7 +5828,7 @@
       </p:sp>
       <p:sp>
         <p:nvSpPr>
-          <p:cNvPr id="16" name="Text 14"/>
+          <p:cNvPr id="15" name="Text 13"/>
           <p:cNvSpPr txBox="1"/>
           <p:nvPr/>
         </p:nvSpPr>
@@ -5743,7 +5859,7 @@
                 <a:ea typeface="Calibri" pitchFamily="34" charset="-122"/>
                 <a:cs typeface="Calibri" pitchFamily="34" charset="-120"/>
               </a:rPr>
-              <a:t>•  Direct Patch() — no Power Automate needed</a:t>
+              <a:t>•  Faults captured and linked to cases in real time</a:t>
             </a:r>
             <a:endParaRPr lang="en-US" sz="1150" dirty="0"/>
           </a:p>
@@ -5751,7 +5867,7 @@
       </p:sp>
       <p:sp>
         <p:nvSpPr>
-          <p:cNvPr id="17" name="Text 15"/>
+          <p:cNvPr id="16" name="Text 14"/>
           <p:cNvSpPr txBox="1"/>
           <p:nvPr/>
         </p:nvSpPr>
@@ -5782,46 +5898,7 @@
                 <a:ea typeface="Calibri" pitchFamily="34" charset="-122"/>
                 <a:cs typeface="Calibri" pitchFamily="34" charset="-120"/>
               </a:rPr>
-              <a:t>•  Standard M365 licence — no premium cost</a:t>
-            </a:r>
-            <a:endParaRPr lang="en-US" sz="1150" dirty="0"/>
-          </a:p>
-        </p:txBody>
-      </p:sp>
-      <p:sp>
-        <p:nvSpPr>
-          <p:cNvPr id="18" name="Text 16"/>
-          <p:cNvSpPr txBox="1"/>
-          <p:nvPr/>
-        </p:nvSpPr>
-        <p:spPr>
-          <a:xfrm>
-            <a:off x="5138928" y="3776472"/>
-            <a:ext cx="3520440" cy="402336"/>
-          </a:xfrm>
-          <a:prstGeom prst="rect">
-            <a:avLst/>
-          </a:prstGeom>
-          <a:noFill/>
-          <a:ln/>
-        </p:spPr>
-        <p:txBody>
-          <a:bodyPr wrap="square" lIns="0" tIns="0" rIns="0" bIns="0" rtlCol="0" anchor="ctr"/>
-          <a:lstStyle/>
-          <a:p>
-            <a:pPr indent="0" marL="0">
-              <a:buNone/>
-            </a:pPr>
-            <a:r>
-              <a:rPr lang="en-US" sz="1150" dirty="0">
-                <a:solidFill>
-                  <a:srgbClr val="1C2230"/>
-                </a:solidFill>
-                <a:latin typeface="Calibri" pitchFamily="34" charset="0"/>
-                <a:ea typeface="Calibri" pitchFamily="34" charset="-122"/>
-                <a:cs typeface="Calibri" pitchFamily="34" charset="-120"/>
-              </a:rPr>
-              <a:t>•  Full audit trail with offline-resilient alerts</a:t>
+              <a:t>•  Complete audit trail — always current, always ready</a:t>
             </a:r>
             <a:endParaRPr lang="en-US" sz="1150" dirty="0"/>
           </a:p>
@@ -5892,7 +5969,7 @@
                 <a:ea typeface="Calibri" pitchFamily="34" charset="-122"/>
                 <a:cs typeface="Calibri" pitchFamily="34" charset="-120"/>
               </a:rPr>
-              <a:t>WHY IT MATTERS</a:t>
+              <a:t>CONTINUOUS IMPROVEMENT</a:t>
             </a:r>
             <a:endParaRPr lang="en-US" sz="850" dirty="0"/>
           </a:p>
@@ -5931,7 +6008,7 @@
                 <a:ea typeface="Calibri" pitchFamily="34" charset="-122"/>
                 <a:cs typeface="Calibri" pitchFamily="34" charset="-120"/>
               </a:rPr>
-              <a:t>Built for Patient Safety and Accountability</a:t>
+              <a:t>Staff Feedback Drives Every Update</a:t>
             </a:r>
             <a:endParaRPr lang="en-US" sz="2800" dirty="0"/>
           </a:p>
@@ -5939,18 +6016,57 @@
       </p:sp>
       <p:sp>
         <p:nvSpPr>
-          <p:cNvPr id="4" name="Shape 2"/>
+          <p:cNvPr id="4" name="Text 2"/>
+          <p:cNvSpPr txBox="1"/>
+          <p:nvPr/>
+        </p:nvSpPr>
+        <p:spPr>
+          <a:xfrm>
+            <a:off x="457200" y="1261872"/>
+            <a:ext cx="8229600" cy="566928"/>
+          </a:xfrm>
+          <a:prstGeom prst="rect">
+            <a:avLst/>
+          </a:prstGeom>
+          <a:noFill/>
+          <a:ln/>
+        </p:spPr>
+        <p:txBody>
+          <a:bodyPr wrap="square" lIns="0" tIns="0" rIns="0" bIns="0" rtlCol="0" anchor="ctr"/>
+          <a:lstStyle/>
+          <a:p>
+            <a:pPr indent="0" marL="0">
+              <a:buNone/>
+            </a:pPr>
+            <a:r>
+              <a:rPr lang="en-US" sz="1250" dirty="0">
+                <a:solidFill>
+                  <a:srgbClr val="1C2230"/>
+                </a:solidFill>
+                <a:latin typeface="Calibri" pitchFamily="34" charset="0"/>
+                <a:ea typeface="Calibri" pitchFamily="34" charset="-122"/>
+                <a:cs typeface="Calibri" pitchFamily="34" charset="-120"/>
+              </a:rPr>
+              <a:t>RISE is a living system. When staff spot an issue or have a suggestion, they message the team directly on WhatsApp. Fixes are implemented and deployed — often the same day.</a:t>
+            </a:r>
+            <a:endParaRPr lang="en-US" sz="1250" dirty="0"/>
+          </a:p>
+        </p:txBody>
+      </p:sp>
+      <p:sp>
+        <p:nvSpPr>
+          <p:cNvPr id="5" name="Shape 3"/>
           <p:cNvSpPr/>
           <p:nvPr/>
         </p:nvSpPr>
         <p:spPr>
           <a:xfrm>
-            <a:off x="411480" y="1143000"/>
-            <a:ext cx="4206240" cy="1600200"/>
+            <a:off x="365760" y="2148840"/>
+            <a:ext cx="1417320" cy="1691640"/>
           </a:xfrm>
           <a:prstGeom prst="roundRect">
             <a:avLst>
-              <a:gd name="adj" fmla="val 4571"/>
+              <a:gd name="adj" fmla="val 5161"/>
             </a:avLst>
           </a:prstGeom>
           <a:solidFill>
@@ -5966,14 +6082,200 @@
       </p:sp>
       <p:sp>
         <p:nvSpPr>
-          <p:cNvPr id="5" name="Shape 3"/>
+          <p:cNvPr id="6" name="Shape 4"/>
           <p:cNvSpPr/>
           <p:nvPr/>
         </p:nvSpPr>
         <p:spPr>
           <a:xfrm>
-            <a:off x="612648" y="1719072"/>
-            <a:ext cx="475488" cy="475488"/>
+            <a:off x="822960" y="2331720"/>
+            <a:ext cx="502920" cy="502920"/>
+          </a:xfrm>
+          <a:prstGeom prst="ellipse">
+            <a:avLst/>
+          </a:prstGeom>
+          <a:solidFill>
+            <a:srgbClr val="002D4A"/>
+          </a:solidFill>
+          <a:ln w="12700">
+            <a:solidFill>
+              <a:srgbClr val="002D4A"/>
+            </a:solidFill>
+            <a:prstDash val="solid"/>
+          </a:ln>
+        </p:spPr>
+      </p:sp>
+      <p:sp>
+        <p:nvSpPr>
+          <p:cNvPr id="7" name="Text 5"/>
+          <p:cNvSpPr txBox="1"/>
+          <p:nvPr/>
+        </p:nvSpPr>
+        <p:spPr>
+          <a:xfrm>
+            <a:off x="822960" y="2331720"/>
+            <a:ext cx="502920" cy="502920"/>
+          </a:xfrm>
+          <a:prstGeom prst="rect">
+            <a:avLst/>
+          </a:prstGeom>
+          <a:noFill/>
+          <a:ln/>
+        </p:spPr>
+        <p:txBody>
+          <a:bodyPr wrap="square" lIns="0" tIns="0" rIns="0" bIns="0" rtlCol="0" anchor="ctr"/>
+          <a:lstStyle/>
+          <a:p>
+            <a:pPr algn="ctr" indent="0" marL="0">
+              <a:buNone/>
+            </a:pPr>
+            <a:r>
+              <a:rPr lang="en-US" sz="900" b="1" dirty="0">
+                <a:solidFill>
+                  <a:srgbClr val="FFFFFF"/>
+                </a:solidFill>
+                <a:latin typeface="Calibri" pitchFamily="34" charset="0"/>
+                <a:ea typeface="Calibri" pitchFamily="34" charset="-122"/>
+                <a:cs typeface="Calibri" pitchFamily="34" charset="-120"/>
+              </a:rPr>
+              <a:t>1</a:t>
+            </a:r>
+            <a:endParaRPr lang="en-US" sz="900" dirty="0"/>
+          </a:p>
+        </p:txBody>
+      </p:sp>
+      <p:sp>
+        <p:nvSpPr>
+          <p:cNvPr id="8" name="Text 6"/>
+          <p:cNvSpPr txBox="1"/>
+          <p:nvPr/>
+        </p:nvSpPr>
+        <p:spPr>
+          <a:xfrm>
+            <a:off x="411480" y="2971800"/>
+            <a:ext cx="1325880" cy="731520"/>
+          </a:xfrm>
+          <a:prstGeom prst="rect">
+            <a:avLst/>
+          </a:prstGeom>
+          <a:noFill/>
+          <a:ln/>
+        </p:spPr>
+        <p:txBody>
+          <a:bodyPr wrap="square" lIns="0" tIns="0" rIns="0" bIns="0" rtlCol="0" anchor="ctr"/>
+          <a:lstStyle/>
+          <a:p>
+            <a:pPr algn="ctr" indent="0" marL="0">
+              <a:buNone/>
+            </a:pPr>
+            <a:r>
+              <a:rPr lang="en-US" sz="1050" b="1" dirty="0">
+                <a:solidFill>
+                  <a:srgbClr val="002D4A"/>
+                </a:solidFill>
+                <a:latin typeface="Calibri" pitchFamily="34" charset="0"/>
+                <a:ea typeface="Calibri" pitchFamily="34" charset="-122"/>
+                <a:cs typeface="Calibri" pitchFamily="34" charset="-120"/>
+              </a:rPr>
+              <a:t>Staff use</a:t>
+            </a:r>
+            <a:endParaRPr lang="en-US" sz="1050" dirty="0"/>
+          </a:p>
+          <a:p>
+            <a:pPr algn="ctr" indent="0" marL="0">
+              <a:buNone/>
+            </a:pPr>
+            <a:r>
+              <a:rPr lang="en-US" sz="1050" b="1" dirty="0">
+                <a:solidFill>
+                  <a:srgbClr val="002D4A"/>
+                </a:solidFill>
+                <a:latin typeface="Calibri" pitchFamily="34" charset="0"/>
+                <a:ea typeface="Calibri" pitchFamily="34" charset="-122"/>
+                <a:cs typeface="Calibri" pitchFamily="34" charset="-120"/>
+              </a:rPr>
+              <a:t>RISE in OT</a:t>
+            </a:r>
+            <a:endParaRPr lang="en-US" sz="1050" dirty="0"/>
+          </a:p>
+        </p:txBody>
+      </p:sp>
+      <p:sp>
+        <p:nvSpPr>
+          <p:cNvPr id="9" name="Text 7"/>
+          <p:cNvSpPr txBox="1"/>
+          <p:nvPr/>
+        </p:nvSpPr>
+        <p:spPr>
+          <a:xfrm>
+            <a:off x="1828800" y="2651760"/>
+            <a:ext cx="182880" cy="365760"/>
+          </a:xfrm>
+          <a:prstGeom prst="rect">
+            <a:avLst/>
+          </a:prstGeom>
+          <a:noFill/>
+          <a:ln/>
+        </p:spPr>
+        <p:txBody>
+          <a:bodyPr wrap="square" lIns="0" tIns="0" rIns="0" bIns="0" rtlCol="0" anchor="ctr"/>
+          <a:lstStyle/>
+          <a:p>
+            <a:pPr algn="ctr" indent="0" marL="0">
+              <a:buNone/>
+            </a:pPr>
+            <a:r>
+              <a:rPr lang="en-US" sz="1600" b="1" dirty="0">
+                <a:solidFill>
+                  <a:srgbClr val="00606E"/>
+                </a:solidFill>
+                <a:latin typeface="Calibri" pitchFamily="34" charset="0"/>
+                <a:ea typeface="Calibri" pitchFamily="34" charset="-122"/>
+                <a:cs typeface="Calibri" pitchFamily="34" charset="-120"/>
+              </a:rPr>
+              <a:t>→</a:t>
+            </a:r>
+            <a:endParaRPr lang="en-US" sz="1600" dirty="0"/>
+          </a:p>
+        </p:txBody>
+      </p:sp>
+      <p:sp>
+        <p:nvSpPr>
+          <p:cNvPr id="10" name="Shape 8"/>
+          <p:cNvSpPr/>
+          <p:nvPr/>
+        </p:nvSpPr>
+        <p:spPr>
+          <a:xfrm>
+            <a:off x="2057400" y="2148840"/>
+            <a:ext cx="1417320" cy="1691640"/>
+          </a:xfrm>
+          <a:prstGeom prst="roundRect">
+            <a:avLst>
+              <a:gd name="adj" fmla="val 5161"/>
+            </a:avLst>
+          </a:prstGeom>
+          <a:solidFill>
+            <a:srgbClr val="FFFFFF"/>
+          </a:solidFill>
+          <a:ln w="12700">
+            <a:solidFill>
+              <a:srgbClr val="C8E0E6"/>
+            </a:solidFill>
+            <a:prstDash val="solid"/>
+          </a:ln>
+        </p:spPr>
+      </p:sp>
+      <p:sp>
+        <p:nvSpPr>
+          <p:cNvPr id="11" name="Shape 9"/>
+          <p:cNvSpPr/>
+          <p:nvPr/>
+        </p:nvSpPr>
+        <p:spPr>
+          <a:xfrm>
+            <a:off x="2514600" y="2331720"/>
+            <a:ext cx="502920" cy="502920"/>
           </a:xfrm>
           <a:prstGeom prst="ellipse">
             <a:avLst/>
@@ -5991,14 +6293,14 @@
       </p:sp>
       <p:sp>
         <p:nvSpPr>
-          <p:cNvPr id="6" name="Text 4"/>
-          <p:cNvSpPr txBox="1"/>
-          <p:nvPr/>
-        </p:nvSpPr>
-        <p:spPr>
-          <a:xfrm>
-            <a:off x="612648" y="1719072"/>
-            <a:ext cx="475488" cy="475488"/>
+          <p:cNvPr id="12" name="Text 10"/>
+          <p:cNvSpPr txBox="1"/>
+          <p:nvPr/>
+        </p:nvSpPr>
+        <p:spPr>
+          <a:xfrm>
+            <a:off x="2514600" y="2331720"/>
+            <a:ext cx="502920" cy="502920"/>
           </a:xfrm>
           <a:prstGeom prst="rect">
             <a:avLst/>
@@ -6022,7 +6324,7 @@
                 <a:ea typeface="Calibri" pitchFamily="34" charset="-122"/>
                 <a:cs typeface="Calibri" pitchFamily="34" charset="-120"/>
               </a:rPr>
-              <a:t>S</a:t>
+              <a:t>2</a:t>
             </a:r>
             <a:endParaRPr lang="en-US" sz="900" dirty="0"/>
           </a:p>
@@ -6030,30 +6332,30 @@
       </p:sp>
       <p:sp>
         <p:nvSpPr>
-          <p:cNvPr id="7" name="Text 5"/>
-          <p:cNvSpPr txBox="1"/>
-          <p:nvPr/>
-        </p:nvSpPr>
-        <p:spPr>
-          <a:xfrm>
-            <a:off x="1216152" y="1307592"/>
-            <a:ext cx="3218688" cy="365760"/>
-          </a:xfrm>
-          <a:prstGeom prst="rect">
-            <a:avLst/>
-          </a:prstGeom>
-          <a:noFill/>
-          <a:ln/>
-        </p:spPr>
-        <p:txBody>
-          <a:bodyPr wrap="square" lIns="0" tIns="0" rIns="0" bIns="0" rtlCol="0" anchor="ctr"/>
-          <a:lstStyle/>
-          <a:p>
-            <a:pPr indent="0" marL="0">
-              <a:buNone/>
-            </a:pPr>
-            <a:r>
-              <a:rPr lang="en-US" sz="1350" b="1" dirty="0">
+          <p:cNvPr id="13" name="Text 11"/>
+          <p:cNvSpPr txBox="1"/>
+          <p:nvPr/>
+        </p:nvSpPr>
+        <p:spPr>
+          <a:xfrm>
+            <a:off x="2103120" y="2971800"/>
+            <a:ext cx="1325880" cy="731520"/>
+          </a:xfrm>
+          <a:prstGeom prst="rect">
+            <a:avLst/>
+          </a:prstGeom>
+          <a:noFill/>
+          <a:ln/>
+        </p:spPr>
+        <p:txBody>
+          <a:bodyPr wrap="square" lIns="0" tIns="0" rIns="0" bIns="0" rtlCol="0" anchor="ctr"/>
+          <a:lstStyle/>
+          <a:p>
+            <a:pPr algn="ctr" indent="0" marL="0">
+              <a:buNone/>
+            </a:pPr>
+            <a:r>
+              <a:rPr lang="en-US" sz="1050" b="1" dirty="0">
                 <a:solidFill>
                   <a:srgbClr val="002D4A"/>
                 </a:solidFill>
@@ -6061,65 +6363,82 @@
                 <a:ea typeface="Calibri" pitchFamily="34" charset="-122"/>
                 <a:cs typeface="Calibri" pitchFamily="34" charset="-120"/>
               </a:rPr>
-              <a:t>Safer instruments</a:t>
-            </a:r>
-            <a:endParaRPr lang="en-US" sz="1350" dirty="0"/>
-          </a:p>
-        </p:txBody>
-      </p:sp>
-      <p:sp>
-        <p:nvSpPr>
-          <p:cNvPr id="8" name="Text 6"/>
-          <p:cNvSpPr txBox="1"/>
-          <p:nvPr/>
-        </p:nvSpPr>
-        <p:spPr>
-          <a:xfrm>
-            <a:off x="1216152" y="1728216"/>
-            <a:ext cx="3218688" cy="877824"/>
-          </a:xfrm>
-          <a:prstGeom prst="rect">
-            <a:avLst/>
-          </a:prstGeom>
-          <a:noFill/>
-          <a:ln/>
-        </p:spPr>
-        <p:txBody>
-          <a:bodyPr wrap="square" lIns="0" tIns="0" rIns="0" bIns="0" rtlCol="0" anchor="ctr"/>
-          <a:lstStyle/>
-          <a:p>
-            <a:pPr indent="0" marL="0">
-              <a:buNone/>
-            </a:pPr>
-            <a:r>
-              <a:rPr lang="en-US" sz="1100" dirty="0">
-                <a:solidFill>
-                  <a:srgbClr val="4A5568"/>
-                </a:solidFill>
-                <a:latin typeface="Calibri" pitchFamily="34" charset="0"/>
-                <a:ea typeface="Calibri" pitchFamily="34" charset="-122"/>
-                <a:cs typeface="Calibri" pitchFamily="34" charset="-120"/>
-              </a:rPr>
-              <a:t>Real-time use counts and status flags mean instruments are never unknowingly overused or overlooked.</a:t>
-            </a:r>
-            <a:endParaRPr lang="en-US" sz="1100" dirty="0"/>
-          </a:p>
-        </p:txBody>
-      </p:sp>
-      <p:sp>
-        <p:nvSpPr>
-          <p:cNvPr id="9" name="Shape 7"/>
+              <a:t>Issue or idea</a:t>
+            </a:r>
+            <a:endParaRPr lang="en-US" sz="1050" dirty="0"/>
+          </a:p>
+          <a:p>
+            <a:pPr algn="ctr" indent="0" marL="0">
+              <a:buNone/>
+            </a:pPr>
+            <a:r>
+              <a:rPr lang="en-US" sz="1050" b="1" dirty="0">
+                <a:solidFill>
+                  <a:srgbClr val="002D4A"/>
+                </a:solidFill>
+                <a:latin typeface="Calibri" pitchFamily="34" charset="0"/>
+                <a:ea typeface="Calibri" pitchFamily="34" charset="-122"/>
+                <a:cs typeface="Calibri" pitchFamily="34" charset="-120"/>
+              </a:rPr>
+              <a:t>spotted</a:t>
+            </a:r>
+            <a:endParaRPr lang="en-US" sz="1050" dirty="0"/>
+          </a:p>
+        </p:txBody>
+      </p:sp>
+      <p:sp>
+        <p:nvSpPr>
+          <p:cNvPr id="14" name="Text 12"/>
+          <p:cNvSpPr txBox="1"/>
+          <p:nvPr/>
+        </p:nvSpPr>
+        <p:spPr>
+          <a:xfrm>
+            <a:off x="3520440" y="2651760"/>
+            <a:ext cx="182880" cy="365760"/>
+          </a:xfrm>
+          <a:prstGeom prst="rect">
+            <a:avLst/>
+          </a:prstGeom>
+          <a:noFill/>
+          <a:ln/>
+        </p:spPr>
+        <p:txBody>
+          <a:bodyPr wrap="square" lIns="0" tIns="0" rIns="0" bIns="0" rtlCol="0" anchor="ctr"/>
+          <a:lstStyle/>
+          <a:p>
+            <a:pPr algn="ctr" indent="0" marL="0">
+              <a:buNone/>
+            </a:pPr>
+            <a:r>
+              <a:rPr lang="en-US" sz="1600" b="1" dirty="0">
+                <a:solidFill>
+                  <a:srgbClr val="00606E"/>
+                </a:solidFill>
+                <a:latin typeface="Calibri" pitchFamily="34" charset="0"/>
+                <a:ea typeface="Calibri" pitchFamily="34" charset="-122"/>
+                <a:cs typeface="Calibri" pitchFamily="34" charset="-120"/>
+              </a:rPr>
+              <a:t>→</a:t>
+            </a:r>
+            <a:endParaRPr lang="en-US" sz="1600" dirty="0"/>
+          </a:p>
+        </p:txBody>
+      </p:sp>
+      <p:sp>
+        <p:nvSpPr>
+          <p:cNvPr id="15" name="Shape 13"/>
           <p:cNvSpPr/>
           <p:nvPr/>
         </p:nvSpPr>
         <p:spPr>
           <a:xfrm>
-            <a:off x="4800600" y="1143000"/>
-            <a:ext cx="4206240" cy="1600200"/>
+            <a:off x="3749040" y="2148840"/>
+            <a:ext cx="1417320" cy="1691640"/>
           </a:xfrm>
           <a:prstGeom prst="roundRect">
             <a:avLst>
-              <a:gd name="adj" fmla="val 4571"/>
+              <a:gd name="adj" fmla="val 5161"/>
             </a:avLst>
           </a:prstGeom>
           <a:solidFill>
@@ -6135,14 +6454,386 @@
       </p:sp>
       <p:sp>
         <p:nvSpPr>
-          <p:cNvPr id="10" name="Shape 8"/>
+          <p:cNvPr id="16" name="Shape 14"/>
           <p:cNvSpPr/>
           <p:nvPr/>
         </p:nvSpPr>
         <p:spPr>
           <a:xfrm>
-            <a:off x="5001768" y="1719072"/>
-            <a:ext cx="475488" cy="475488"/>
+            <a:off x="4206240" y="2331720"/>
+            <a:ext cx="502920" cy="502920"/>
+          </a:xfrm>
+          <a:prstGeom prst="ellipse">
+            <a:avLst/>
+          </a:prstGeom>
+          <a:solidFill>
+            <a:srgbClr val="008C9E"/>
+          </a:solidFill>
+          <a:ln w="12700">
+            <a:solidFill>
+              <a:srgbClr val="008C9E"/>
+            </a:solidFill>
+            <a:prstDash val="solid"/>
+          </a:ln>
+        </p:spPr>
+      </p:sp>
+      <p:sp>
+        <p:nvSpPr>
+          <p:cNvPr id="17" name="Text 15"/>
+          <p:cNvSpPr txBox="1"/>
+          <p:nvPr/>
+        </p:nvSpPr>
+        <p:spPr>
+          <a:xfrm>
+            <a:off x="4206240" y="2331720"/>
+            <a:ext cx="502920" cy="502920"/>
+          </a:xfrm>
+          <a:prstGeom prst="rect">
+            <a:avLst/>
+          </a:prstGeom>
+          <a:noFill/>
+          <a:ln/>
+        </p:spPr>
+        <p:txBody>
+          <a:bodyPr wrap="square" lIns="0" tIns="0" rIns="0" bIns="0" rtlCol="0" anchor="ctr"/>
+          <a:lstStyle/>
+          <a:p>
+            <a:pPr algn="ctr" indent="0" marL="0">
+              <a:buNone/>
+            </a:pPr>
+            <a:r>
+              <a:rPr lang="en-US" sz="900" b="1" dirty="0">
+                <a:solidFill>
+                  <a:srgbClr val="FFFFFF"/>
+                </a:solidFill>
+                <a:latin typeface="Calibri" pitchFamily="34" charset="0"/>
+                <a:ea typeface="Calibri" pitchFamily="34" charset="-122"/>
+                <a:cs typeface="Calibri" pitchFamily="34" charset="-120"/>
+              </a:rPr>
+              <a:t>3</a:t>
+            </a:r>
+            <a:endParaRPr lang="en-US" sz="900" dirty="0"/>
+          </a:p>
+        </p:txBody>
+      </p:sp>
+      <p:sp>
+        <p:nvSpPr>
+          <p:cNvPr id="18" name="Text 16"/>
+          <p:cNvSpPr txBox="1"/>
+          <p:nvPr/>
+        </p:nvSpPr>
+        <p:spPr>
+          <a:xfrm>
+            <a:off x="3794760" y="2971800"/>
+            <a:ext cx="1325880" cy="731520"/>
+          </a:xfrm>
+          <a:prstGeom prst="rect">
+            <a:avLst/>
+          </a:prstGeom>
+          <a:noFill/>
+          <a:ln/>
+        </p:spPr>
+        <p:txBody>
+          <a:bodyPr wrap="square" lIns="0" tIns="0" rIns="0" bIns="0" rtlCol="0" anchor="ctr"/>
+          <a:lstStyle/>
+          <a:p>
+            <a:pPr algn="ctr" indent="0" marL="0">
+              <a:buNone/>
+            </a:pPr>
+            <a:r>
+              <a:rPr lang="en-US" sz="1050" b="1" dirty="0">
+                <a:solidFill>
+                  <a:srgbClr val="002D4A"/>
+                </a:solidFill>
+                <a:latin typeface="Calibri" pitchFamily="34" charset="0"/>
+                <a:ea typeface="Calibri" pitchFamily="34" charset="-122"/>
+                <a:cs typeface="Calibri" pitchFamily="34" charset="-120"/>
+              </a:rPr>
+              <a:t>Feedback via</a:t>
+            </a:r>
+            <a:endParaRPr lang="en-US" sz="1050" dirty="0"/>
+          </a:p>
+          <a:p>
+            <a:pPr algn="ctr" indent="0" marL="0">
+              <a:buNone/>
+            </a:pPr>
+            <a:r>
+              <a:rPr lang="en-US" sz="1050" b="1" dirty="0">
+                <a:solidFill>
+                  <a:srgbClr val="002D4A"/>
+                </a:solidFill>
+                <a:latin typeface="Calibri" pitchFamily="34" charset="0"/>
+                <a:ea typeface="Calibri" pitchFamily="34" charset="-122"/>
+                <a:cs typeface="Calibri" pitchFamily="34" charset="-120"/>
+              </a:rPr>
+              <a:t>WhatsApp</a:t>
+            </a:r>
+            <a:endParaRPr lang="en-US" sz="1050" dirty="0"/>
+          </a:p>
+        </p:txBody>
+      </p:sp>
+      <p:sp>
+        <p:nvSpPr>
+          <p:cNvPr id="19" name="Text 17"/>
+          <p:cNvSpPr txBox="1"/>
+          <p:nvPr/>
+        </p:nvSpPr>
+        <p:spPr>
+          <a:xfrm>
+            <a:off x="5212080" y="2651760"/>
+            <a:ext cx="182880" cy="365760"/>
+          </a:xfrm>
+          <a:prstGeom prst="rect">
+            <a:avLst/>
+          </a:prstGeom>
+          <a:noFill/>
+          <a:ln/>
+        </p:spPr>
+        <p:txBody>
+          <a:bodyPr wrap="square" lIns="0" tIns="0" rIns="0" bIns="0" rtlCol="0" anchor="ctr"/>
+          <a:lstStyle/>
+          <a:p>
+            <a:pPr algn="ctr" indent="0" marL="0">
+              <a:buNone/>
+            </a:pPr>
+            <a:r>
+              <a:rPr lang="en-US" sz="1600" b="1" dirty="0">
+                <a:solidFill>
+                  <a:srgbClr val="00606E"/>
+                </a:solidFill>
+                <a:latin typeface="Calibri" pitchFamily="34" charset="0"/>
+                <a:ea typeface="Calibri" pitchFamily="34" charset="-122"/>
+                <a:cs typeface="Calibri" pitchFamily="34" charset="-120"/>
+              </a:rPr>
+              <a:t>→</a:t>
+            </a:r>
+            <a:endParaRPr lang="en-US" sz="1600" dirty="0"/>
+          </a:p>
+        </p:txBody>
+      </p:sp>
+      <p:sp>
+        <p:nvSpPr>
+          <p:cNvPr id="20" name="Shape 18"/>
+          <p:cNvSpPr/>
+          <p:nvPr/>
+        </p:nvSpPr>
+        <p:spPr>
+          <a:xfrm>
+            <a:off x="5440680" y="2148840"/>
+            <a:ext cx="1417320" cy="1691640"/>
+          </a:xfrm>
+          <a:prstGeom prst="roundRect">
+            <a:avLst>
+              <a:gd name="adj" fmla="val 5161"/>
+            </a:avLst>
+          </a:prstGeom>
+          <a:solidFill>
+            <a:srgbClr val="FFFFFF"/>
+          </a:solidFill>
+          <a:ln w="12700">
+            <a:solidFill>
+              <a:srgbClr val="C8E0E6"/>
+            </a:solidFill>
+            <a:prstDash val="solid"/>
+          </a:ln>
+        </p:spPr>
+      </p:sp>
+      <p:sp>
+        <p:nvSpPr>
+          <p:cNvPr id="21" name="Shape 19"/>
+          <p:cNvSpPr/>
+          <p:nvPr/>
+        </p:nvSpPr>
+        <p:spPr>
+          <a:xfrm>
+            <a:off x="5897880" y="2331720"/>
+            <a:ext cx="502920" cy="502920"/>
+          </a:xfrm>
+          <a:prstGeom prst="ellipse">
+            <a:avLst/>
+          </a:prstGeom>
+          <a:solidFill>
+            <a:srgbClr val="D97706"/>
+          </a:solidFill>
+          <a:ln w="12700">
+            <a:solidFill>
+              <a:srgbClr val="D97706"/>
+            </a:solidFill>
+            <a:prstDash val="solid"/>
+          </a:ln>
+        </p:spPr>
+      </p:sp>
+      <p:sp>
+        <p:nvSpPr>
+          <p:cNvPr id="22" name="Text 20"/>
+          <p:cNvSpPr txBox="1"/>
+          <p:nvPr/>
+        </p:nvSpPr>
+        <p:spPr>
+          <a:xfrm>
+            <a:off x="5897880" y="2331720"/>
+            <a:ext cx="502920" cy="502920"/>
+          </a:xfrm>
+          <a:prstGeom prst="rect">
+            <a:avLst/>
+          </a:prstGeom>
+          <a:noFill/>
+          <a:ln/>
+        </p:spPr>
+        <p:txBody>
+          <a:bodyPr wrap="square" lIns="0" tIns="0" rIns="0" bIns="0" rtlCol="0" anchor="ctr"/>
+          <a:lstStyle/>
+          <a:p>
+            <a:pPr algn="ctr" indent="0" marL="0">
+              <a:buNone/>
+            </a:pPr>
+            <a:r>
+              <a:rPr lang="en-US" sz="900" b="1" dirty="0">
+                <a:solidFill>
+                  <a:srgbClr val="FFFFFF"/>
+                </a:solidFill>
+                <a:latin typeface="Calibri" pitchFamily="34" charset="0"/>
+                <a:ea typeface="Calibri" pitchFamily="34" charset="-122"/>
+                <a:cs typeface="Calibri" pitchFamily="34" charset="-120"/>
+              </a:rPr>
+              <a:t>4</a:t>
+            </a:r>
+            <a:endParaRPr lang="en-US" sz="900" dirty="0"/>
+          </a:p>
+        </p:txBody>
+      </p:sp>
+      <p:sp>
+        <p:nvSpPr>
+          <p:cNvPr id="23" name="Text 21"/>
+          <p:cNvSpPr txBox="1"/>
+          <p:nvPr/>
+        </p:nvSpPr>
+        <p:spPr>
+          <a:xfrm>
+            <a:off x="5486400" y="2971800"/>
+            <a:ext cx="1325880" cy="731520"/>
+          </a:xfrm>
+          <a:prstGeom prst="rect">
+            <a:avLst/>
+          </a:prstGeom>
+          <a:noFill/>
+          <a:ln/>
+        </p:spPr>
+        <p:txBody>
+          <a:bodyPr wrap="square" lIns="0" tIns="0" rIns="0" bIns="0" rtlCol="0" anchor="ctr"/>
+          <a:lstStyle/>
+          <a:p>
+            <a:pPr algn="ctr" indent="0" marL="0">
+              <a:buNone/>
+            </a:pPr>
+            <a:r>
+              <a:rPr lang="en-US" sz="1050" b="1" dirty="0">
+                <a:solidFill>
+                  <a:srgbClr val="002D4A"/>
+                </a:solidFill>
+                <a:latin typeface="Calibri" pitchFamily="34" charset="0"/>
+                <a:ea typeface="Calibri" pitchFamily="34" charset="-122"/>
+                <a:cs typeface="Calibri" pitchFamily="34" charset="-120"/>
+              </a:rPr>
+              <a:t>Fix built</a:t>
+            </a:r>
+            <a:endParaRPr lang="en-US" sz="1050" dirty="0"/>
+          </a:p>
+          <a:p>
+            <a:pPr algn="ctr" indent="0" marL="0">
+              <a:buNone/>
+            </a:pPr>
+            <a:r>
+              <a:rPr lang="en-US" sz="1050" b="1" dirty="0">
+                <a:solidFill>
+                  <a:srgbClr val="002D4A"/>
+                </a:solidFill>
+                <a:latin typeface="Calibri" pitchFamily="34" charset="0"/>
+                <a:ea typeface="Calibri" pitchFamily="34" charset="-122"/>
+                <a:cs typeface="Calibri" pitchFamily="34" charset="-120"/>
+              </a:rPr>
+              <a:t>and tested</a:t>
+            </a:r>
+            <a:endParaRPr lang="en-US" sz="1050" dirty="0"/>
+          </a:p>
+        </p:txBody>
+      </p:sp>
+      <p:sp>
+        <p:nvSpPr>
+          <p:cNvPr id="24" name="Text 22"/>
+          <p:cNvSpPr txBox="1"/>
+          <p:nvPr/>
+        </p:nvSpPr>
+        <p:spPr>
+          <a:xfrm>
+            <a:off x="6903720" y="2651760"/>
+            <a:ext cx="182880" cy="365760"/>
+          </a:xfrm>
+          <a:prstGeom prst="rect">
+            <a:avLst/>
+          </a:prstGeom>
+          <a:noFill/>
+          <a:ln/>
+        </p:spPr>
+        <p:txBody>
+          <a:bodyPr wrap="square" lIns="0" tIns="0" rIns="0" bIns="0" rtlCol="0" anchor="ctr"/>
+          <a:lstStyle/>
+          <a:p>
+            <a:pPr algn="ctr" indent="0" marL="0">
+              <a:buNone/>
+            </a:pPr>
+            <a:r>
+              <a:rPr lang="en-US" sz="1600" b="1" dirty="0">
+                <a:solidFill>
+                  <a:srgbClr val="00606E"/>
+                </a:solidFill>
+                <a:latin typeface="Calibri" pitchFamily="34" charset="0"/>
+                <a:ea typeface="Calibri" pitchFamily="34" charset="-122"/>
+                <a:cs typeface="Calibri" pitchFamily="34" charset="-120"/>
+              </a:rPr>
+              <a:t>→</a:t>
+            </a:r>
+            <a:endParaRPr lang="en-US" sz="1600" dirty="0"/>
+          </a:p>
+        </p:txBody>
+      </p:sp>
+      <p:sp>
+        <p:nvSpPr>
+          <p:cNvPr id="25" name="Shape 23"/>
+          <p:cNvSpPr/>
+          <p:nvPr/>
+        </p:nvSpPr>
+        <p:spPr>
+          <a:xfrm>
+            <a:off x="7132320" y="2148840"/>
+            <a:ext cx="1417320" cy="1691640"/>
+          </a:xfrm>
+          <a:prstGeom prst="roundRect">
+            <a:avLst>
+              <a:gd name="adj" fmla="val 5161"/>
+            </a:avLst>
+          </a:prstGeom>
+          <a:solidFill>
+            <a:srgbClr val="FFFFFF"/>
+          </a:solidFill>
+          <a:ln w="12700">
+            <a:solidFill>
+              <a:srgbClr val="C8E0E6"/>
+            </a:solidFill>
+            <a:prstDash val="solid"/>
+          </a:ln>
+        </p:spPr>
+      </p:sp>
+      <p:sp>
+        <p:nvSpPr>
+          <p:cNvPr id="26" name="Shape 24"/>
+          <p:cNvSpPr/>
+          <p:nvPr/>
+        </p:nvSpPr>
+        <p:spPr>
+          <a:xfrm>
+            <a:off x="7589520" y="2331720"/>
+            <a:ext cx="502920" cy="502920"/>
           </a:xfrm>
           <a:prstGeom prst="ellipse">
             <a:avLst/>
@@ -6160,14 +6851,14 @@
       </p:sp>
       <p:sp>
         <p:nvSpPr>
-          <p:cNvPr id="11" name="Text 9"/>
-          <p:cNvSpPr txBox="1"/>
-          <p:nvPr/>
-        </p:nvSpPr>
-        <p:spPr>
-          <a:xfrm>
-            <a:off x="5001768" y="1719072"/>
-            <a:ext cx="475488" cy="475488"/>
+          <p:cNvPr id="27" name="Text 25"/>
+          <p:cNvSpPr txBox="1"/>
+          <p:nvPr/>
+        </p:nvSpPr>
+        <p:spPr>
+          <a:xfrm>
+            <a:off x="7589520" y="2331720"/>
+            <a:ext cx="502920" cy="502920"/>
           </a:xfrm>
           <a:prstGeom prst="rect">
             <a:avLst/>
@@ -6191,7 +6882,7 @@
                 <a:ea typeface="Calibri" pitchFamily="34" charset="-122"/>
                 <a:cs typeface="Calibri" pitchFamily="34" charset="-120"/>
               </a:rPr>
-              <a:t>A</a:t>
+              <a:t>5</a:t>
             </a:r>
             <a:endParaRPr lang="en-US" sz="900" dirty="0"/>
           </a:p>
@@ -6199,30 +6890,30 @@
       </p:sp>
       <p:sp>
         <p:nvSpPr>
-          <p:cNvPr id="12" name="Text 10"/>
-          <p:cNvSpPr txBox="1"/>
-          <p:nvPr/>
-        </p:nvSpPr>
-        <p:spPr>
-          <a:xfrm>
-            <a:off x="5605272" y="1307592"/>
-            <a:ext cx="3218688" cy="365760"/>
-          </a:xfrm>
-          <a:prstGeom prst="rect">
-            <a:avLst/>
-          </a:prstGeom>
-          <a:noFill/>
-          <a:ln/>
-        </p:spPr>
-        <p:txBody>
-          <a:bodyPr wrap="square" lIns="0" tIns="0" rIns="0" bIns="0" rtlCol="0" anchor="ctr"/>
-          <a:lstStyle/>
-          <a:p>
-            <a:pPr indent="0" marL="0">
-              <a:buNone/>
-            </a:pPr>
-            <a:r>
-              <a:rPr lang="en-US" sz="1350" b="1" dirty="0">
+          <p:cNvPr id="28" name="Text 26"/>
+          <p:cNvSpPr txBox="1"/>
+          <p:nvPr/>
+        </p:nvSpPr>
+        <p:spPr>
+          <a:xfrm>
+            <a:off x="7178040" y="2971800"/>
+            <a:ext cx="1325880" cy="731520"/>
+          </a:xfrm>
+          <a:prstGeom prst="rect">
+            <a:avLst/>
+          </a:prstGeom>
+          <a:noFill/>
+          <a:ln/>
+        </p:spPr>
+        <p:txBody>
+          <a:bodyPr wrap="square" lIns="0" tIns="0" rIns="0" bIns="0" rtlCol="0" anchor="ctr"/>
+          <a:lstStyle/>
+          <a:p>
+            <a:pPr algn="ctr" indent="0" marL="0">
+              <a:buNone/>
+            </a:pPr>
+            <a:r>
+              <a:rPr lang="en-US" sz="1050" b="1" dirty="0">
                 <a:solidFill>
                   <a:srgbClr val="002D4A"/>
                 </a:solidFill>
@@ -6230,38 +6921,55 @@
                 <a:ea typeface="Calibri" pitchFamily="34" charset="-122"/>
                 <a:cs typeface="Calibri" pitchFamily="34" charset="-120"/>
               </a:rPr>
-              <a:t>Airtight audit trail</a:t>
-            </a:r>
-            <a:endParaRPr lang="en-US" sz="1350" dirty="0"/>
-          </a:p>
-        </p:txBody>
-      </p:sp>
-      <p:sp>
-        <p:nvSpPr>
-          <p:cNvPr id="13" name="Text 11"/>
-          <p:cNvSpPr txBox="1"/>
-          <p:nvPr/>
-        </p:nvSpPr>
-        <p:spPr>
-          <a:xfrm>
-            <a:off x="5605272" y="1728216"/>
-            <a:ext cx="3218688" cy="877824"/>
-          </a:xfrm>
-          <a:prstGeom prst="rect">
-            <a:avLst/>
-          </a:prstGeom>
-          <a:noFill/>
-          <a:ln/>
-        </p:spPr>
-        <p:txBody>
-          <a:bodyPr wrap="square" lIns="0" tIns="0" rIns="0" bIns="0" rtlCol="0" anchor="ctr"/>
-          <a:lstStyle/>
-          <a:p>
-            <a:pPr indent="0" marL="0">
-              <a:buNone/>
-            </a:pPr>
-            <a:r>
-              <a:rPr lang="en-US" sz="1100" dirty="0">
+              <a:t>Update</a:t>
+            </a:r>
+            <a:endParaRPr lang="en-US" sz="1050" dirty="0"/>
+          </a:p>
+          <a:p>
+            <a:pPr algn="ctr" indent="0" marL="0">
+              <a:buNone/>
+            </a:pPr>
+            <a:r>
+              <a:rPr lang="en-US" sz="1050" b="1" dirty="0">
+                <a:solidFill>
+                  <a:srgbClr val="002D4A"/>
+                </a:solidFill>
+                <a:latin typeface="Calibri" pitchFamily="34" charset="0"/>
+                <a:ea typeface="Calibri" pitchFamily="34" charset="-122"/>
+                <a:cs typeface="Calibri" pitchFamily="34" charset="-120"/>
+              </a:rPr>
+              <a:t>deployed live</a:t>
+            </a:r>
+            <a:endParaRPr lang="en-US" sz="1050" dirty="0"/>
+          </a:p>
+        </p:txBody>
+      </p:sp>
+      <p:sp>
+        <p:nvSpPr>
+          <p:cNvPr id="29" name="Text 27"/>
+          <p:cNvSpPr txBox="1"/>
+          <p:nvPr/>
+        </p:nvSpPr>
+        <p:spPr>
+          <a:xfrm>
+            <a:off x="457200" y="4206240"/>
+            <a:ext cx="8229600" cy="274320"/>
+          </a:xfrm>
+          <a:prstGeom prst="rect">
+            <a:avLst/>
+          </a:prstGeom>
+          <a:noFill/>
+          <a:ln/>
+        </p:spPr>
+        <p:txBody>
+          <a:bodyPr wrap="square" lIns="0" tIns="0" rIns="0" bIns="0" rtlCol="0" anchor="ctr"/>
+          <a:lstStyle/>
+          <a:p>
+            <a:pPr algn="ctr" indent="0" marL="0">
+              <a:buNone/>
+            </a:pPr>
+            <a:r>
+              <a:rPr lang="en-US" sz="1050" i="1" dirty="0">
                 <a:solidFill>
                   <a:srgbClr val="4A5568"/>
                 </a:solidFill>
@@ -6269,347 +6977,9 @@
                 <a:ea typeface="Calibri" pitchFamily="34" charset="-122"/>
                 <a:cs typeface="Calibri" pitchFamily="34" charset="-120"/>
               </a:rPr>
-              <a:t>Every action is permanently recorded, making incident review fast, accurate, and trustworthy.</a:t>
-            </a:r>
-            <a:endParaRPr lang="en-US" sz="1100" dirty="0"/>
-          </a:p>
-        </p:txBody>
-      </p:sp>
-      <p:sp>
-        <p:nvSpPr>
-          <p:cNvPr id="14" name="Shape 12"/>
-          <p:cNvSpPr/>
-          <p:nvPr/>
-        </p:nvSpPr>
-        <p:spPr>
-          <a:xfrm>
-            <a:off x="411480" y="2944368"/>
-            <a:ext cx="4206240" cy="1600200"/>
-          </a:xfrm>
-          <a:prstGeom prst="roundRect">
-            <a:avLst>
-              <a:gd name="adj" fmla="val 4571"/>
-            </a:avLst>
-          </a:prstGeom>
-          <a:solidFill>
-            <a:srgbClr val="FFFFFF"/>
-          </a:solidFill>
-          <a:ln w="12700">
-            <a:solidFill>
-              <a:srgbClr val="C8E0E6"/>
-            </a:solidFill>
-            <a:prstDash val="solid"/>
-          </a:ln>
-        </p:spPr>
-      </p:sp>
-      <p:sp>
-        <p:nvSpPr>
-          <p:cNvPr id="15" name="Shape 13"/>
-          <p:cNvSpPr/>
-          <p:nvPr/>
-        </p:nvSpPr>
-        <p:spPr>
-          <a:xfrm>
-            <a:off x="612648" y="3520440"/>
-            <a:ext cx="475488" cy="475488"/>
-          </a:xfrm>
-          <a:prstGeom prst="ellipse">
-            <a:avLst/>
-          </a:prstGeom>
-          <a:solidFill>
-            <a:srgbClr val="002D4A"/>
-          </a:solidFill>
-          <a:ln w="12700">
-            <a:solidFill>
-              <a:srgbClr val="002D4A"/>
-            </a:solidFill>
-            <a:prstDash val="solid"/>
-          </a:ln>
-        </p:spPr>
-      </p:sp>
-      <p:sp>
-        <p:nvSpPr>
-          <p:cNvPr id="16" name="Text 14"/>
-          <p:cNvSpPr txBox="1"/>
-          <p:nvPr/>
-        </p:nvSpPr>
-        <p:spPr>
-          <a:xfrm>
-            <a:off x="612648" y="3520440"/>
-            <a:ext cx="475488" cy="475488"/>
-          </a:xfrm>
-          <a:prstGeom prst="rect">
-            <a:avLst/>
-          </a:prstGeom>
-          <a:noFill/>
-          <a:ln/>
-        </p:spPr>
-        <p:txBody>
-          <a:bodyPr wrap="square" lIns="0" tIns="0" rIns="0" bIns="0" rtlCol="0" anchor="ctr"/>
-          <a:lstStyle/>
-          <a:p>
-            <a:pPr algn="ctr" indent="0" marL="0">
-              <a:buNone/>
-            </a:pPr>
-            <a:r>
-              <a:rPr lang="en-US" sz="900" b="1" dirty="0">
-                <a:solidFill>
-                  <a:srgbClr val="FFFFFF"/>
-                </a:solidFill>
-                <a:latin typeface="Calibri" pitchFamily="34" charset="0"/>
-                <a:ea typeface="Calibri" pitchFamily="34" charset="-122"/>
-                <a:cs typeface="Calibri" pitchFamily="34" charset="-120"/>
-              </a:rPr>
-              <a:t>E</a:t>
-            </a:r>
-            <a:endParaRPr lang="en-US" sz="900" dirty="0"/>
-          </a:p>
-        </p:txBody>
-      </p:sp>
-      <p:sp>
-        <p:nvSpPr>
-          <p:cNvPr id="17" name="Text 15"/>
-          <p:cNvSpPr txBox="1"/>
-          <p:nvPr/>
-        </p:nvSpPr>
-        <p:spPr>
-          <a:xfrm>
-            <a:off x="1216152" y="3108960"/>
-            <a:ext cx="3218688" cy="365760"/>
-          </a:xfrm>
-          <a:prstGeom prst="rect">
-            <a:avLst/>
-          </a:prstGeom>
-          <a:noFill/>
-          <a:ln/>
-        </p:spPr>
-        <p:txBody>
-          <a:bodyPr wrap="square" lIns="0" tIns="0" rIns="0" bIns="0" rtlCol="0" anchor="ctr"/>
-          <a:lstStyle/>
-          <a:p>
-            <a:pPr indent="0" marL="0">
-              <a:buNone/>
-            </a:pPr>
-            <a:r>
-              <a:rPr lang="en-US" sz="1350" b="1" dirty="0">
-                <a:solidFill>
-                  <a:srgbClr val="002D4A"/>
-                </a:solidFill>
-                <a:latin typeface="Calibri" pitchFamily="34" charset="0"/>
-                <a:ea typeface="Calibri" pitchFamily="34" charset="-122"/>
-                <a:cs typeface="Calibri" pitchFamily="34" charset="-120"/>
-              </a:rPr>
-              <a:t>Efficient operations</a:t>
-            </a:r>
-            <a:endParaRPr lang="en-US" sz="1350" dirty="0"/>
-          </a:p>
-        </p:txBody>
-      </p:sp>
-      <p:sp>
-        <p:nvSpPr>
-          <p:cNvPr id="18" name="Text 16"/>
-          <p:cNvSpPr txBox="1"/>
-          <p:nvPr/>
-        </p:nvSpPr>
-        <p:spPr>
-          <a:xfrm>
-            <a:off x="1216152" y="3529584"/>
-            <a:ext cx="3218688" cy="877824"/>
-          </a:xfrm>
-          <a:prstGeom prst="rect">
-            <a:avLst/>
-          </a:prstGeom>
-          <a:noFill/>
-          <a:ln/>
-        </p:spPr>
-        <p:txBody>
-          <a:bodyPr wrap="square" lIns="0" tIns="0" rIns="0" bIns="0" rtlCol="0" anchor="ctr"/>
-          <a:lstStyle/>
-          <a:p>
-            <a:pPr indent="0" marL="0">
-              <a:buNone/>
-            </a:pPr>
-            <a:r>
-              <a:rPr lang="en-US" sz="1100" dirty="0">
-                <a:solidFill>
-                  <a:srgbClr val="4A5568"/>
-                </a:solidFill>
-                <a:latin typeface="Calibri" pitchFamily="34" charset="0"/>
-                <a:ea typeface="Calibri" pitchFamily="34" charset="-122"/>
-                <a:cs typeface="Calibri" pitchFamily="34" charset="-120"/>
-              </a:rPr>
-              <a:t>Digital workflows replace manual paperwork, saving time and reducing transcription errors in busy OT sessions.</a:t>
-            </a:r>
-            <a:endParaRPr lang="en-US" sz="1100" dirty="0"/>
-          </a:p>
-        </p:txBody>
-      </p:sp>
-      <p:sp>
-        <p:nvSpPr>
-          <p:cNvPr id="19" name="Shape 17"/>
-          <p:cNvSpPr/>
-          <p:nvPr/>
-        </p:nvSpPr>
-        <p:spPr>
-          <a:xfrm>
-            <a:off x="4800600" y="2944368"/>
-            <a:ext cx="4206240" cy="1600200"/>
-          </a:xfrm>
-          <a:prstGeom prst="roundRect">
-            <a:avLst>
-              <a:gd name="adj" fmla="val 4571"/>
-            </a:avLst>
-          </a:prstGeom>
-          <a:solidFill>
-            <a:srgbClr val="FFFFFF"/>
-          </a:solidFill>
-          <a:ln w="12700">
-            <a:solidFill>
-              <a:srgbClr val="C8E0E6"/>
-            </a:solidFill>
-            <a:prstDash val="solid"/>
-          </a:ln>
-        </p:spPr>
-      </p:sp>
-      <p:sp>
-        <p:nvSpPr>
-          <p:cNvPr id="20" name="Shape 18"/>
-          <p:cNvSpPr/>
-          <p:nvPr/>
-        </p:nvSpPr>
-        <p:spPr>
-          <a:xfrm>
-            <a:off x="5001768" y="3520440"/>
-            <a:ext cx="475488" cy="475488"/>
-          </a:xfrm>
-          <a:prstGeom prst="ellipse">
-            <a:avLst/>
-          </a:prstGeom>
-          <a:solidFill>
-            <a:srgbClr val="8B2252"/>
-          </a:solidFill>
-          <a:ln w="12700">
-            <a:solidFill>
-              <a:srgbClr val="8B2252"/>
-            </a:solidFill>
-            <a:prstDash val="solid"/>
-          </a:ln>
-        </p:spPr>
-      </p:sp>
-      <p:sp>
-        <p:nvSpPr>
-          <p:cNvPr id="21" name="Text 19"/>
-          <p:cNvSpPr txBox="1"/>
-          <p:nvPr/>
-        </p:nvSpPr>
-        <p:spPr>
-          <a:xfrm>
-            <a:off x="5001768" y="3520440"/>
-            <a:ext cx="475488" cy="475488"/>
-          </a:xfrm>
-          <a:prstGeom prst="rect">
-            <a:avLst/>
-          </a:prstGeom>
-          <a:noFill/>
-          <a:ln/>
-        </p:spPr>
-        <p:txBody>
-          <a:bodyPr wrap="square" lIns="0" tIns="0" rIns="0" bIns="0" rtlCol="0" anchor="ctr"/>
-          <a:lstStyle/>
-          <a:p>
-            <a:pPr algn="ctr" indent="0" marL="0">
-              <a:buNone/>
-            </a:pPr>
-            <a:r>
-              <a:rPr lang="en-US" sz="900" b="1" dirty="0">
-                <a:solidFill>
-                  <a:srgbClr val="FFFFFF"/>
-                </a:solidFill>
-                <a:latin typeface="Calibri" pitchFamily="34" charset="0"/>
-                <a:ea typeface="Calibri" pitchFamily="34" charset="-122"/>
-                <a:cs typeface="Calibri" pitchFamily="34" charset="-120"/>
-              </a:rPr>
-              <a:t>R</a:t>
-            </a:r>
-            <a:endParaRPr lang="en-US" sz="900" dirty="0"/>
-          </a:p>
-        </p:txBody>
-      </p:sp>
-      <p:sp>
-        <p:nvSpPr>
-          <p:cNvPr id="22" name="Text 20"/>
-          <p:cNvSpPr txBox="1"/>
-          <p:nvPr/>
-        </p:nvSpPr>
-        <p:spPr>
-          <a:xfrm>
-            <a:off x="5605272" y="3108960"/>
-            <a:ext cx="3218688" cy="365760"/>
-          </a:xfrm>
-          <a:prstGeom prst="rect">
-            <a:avLst/>
-          </a:prstGeom>
-          <a:noFill/>
-          <a:ln/>
-        </p:spPr>
-        <p:txBody>
-          <a:bodyPr wrap="square" lIns="0" tIns="0" rIns="0" bIns="0" rtlCol="0" anchor="ctr"/>
-          <a:lstStyle/>
-          <a:p>
-            <a:pPr indent="0" marL="0">
-              <a:buNone/>
-            </a:pPr>
-            <a:r>
-              <a:rPr lang="en-US" sz="1350" b="1" dirty="0">
-                <a:solidFill>
-                  <a:srgbClr val="002D4A"/>
-                </a:solidFill>
-                <a:latin typeface="Calibri" pitchFamily="34" charset="0"/>
-                <a:ea typeface="Calibri" pitchFamily="34" charset="-122"/>
-                <a:cs typeface="Calibri" pitchFamily="34" charset="-120"/>
-              </a:rPr>
-              <a:t>Reduced operational risk</a:t>
-            </a:r>
-            <a:endParaRPr lang="en-US" sz="1350" dirty="0"/>
-          </a:p>
-        </p:txBody>
-      </p:sp>
-      <p:sp>
-        <p:nvSpPr>
-          <p:cNvPr id="23" name="Text 21"/>
-          <p:cNvSpPr txBox="1"/>
-          <p:nvPr/>
-        </p:nvSpPr>
-        <p:spPr>
-          <a:xfrm>
-            <a:off x="5605272" y="3529584"/>
-            <a:ext cx="3218688" cy="877824"/>
-          </a:xfrm>
-          <a:prstGeom prst="rect">
-            <a:avLst/>
-          </a:prstGeom>
-          <a:noFill/>
-          <a:ln/>
-        </p:spPr>
-        <p:txBody>
-          <a:bodyPr wrap="square" lIns="0" tIns="0" rIns="0" bIns="0" rtlCol="0" anchor="ctr"/>
-          <a:lstStyle/>
-          <a:p>
-            <a:pPr indent="0" marL="0">
-              <a:buNone/>
-            </a:pPr>
-            <a:r>
-              <a:rPr lang="en-US" sz="1100" dirty="0">
-                <a:solidFill>
-                  <a:srgbClr val="4A5568"/>
-                </a:solidFill>
-                <a:latin typeface="Calibri" pitchFamily="34" charset="0"/>
-                <a:ea typeface="Calibri" pitchFamily="34" charset="-122"/>
-                <a:cs typeface="Calibri" pitchFamily="34" charset="-120"/>
-              </a:rPr>
-              <a:t>Proactive fault tracking and lifecycle alerts help prevent equipment failures before they happen.</a:t>
-            </a:r>
-            <a:endParaRPr lang="en-US" sz="1100" dirty="0"/>
+              <a:t>No formal ticketing  ·  Direct to developer  ·  Issues resolved fast</a:t>
+            </a:r>
+            <a:endParaRPr lang="en-US" sz="1050" dirty="0"/>
           </a:p>
         </p:txBody>
       </p:sp>
@@ -6624,6 +6994,792 @@
 <file path=ppt/slides/slide8.xml><?xml version="1.0" encoding="utf-8"?>
 <p:sld xmlns:a="http://schemas.openxmlformats.org/drawingml/2006/main" xmlns:r="http://schemas.openxmlformats.org/officeDocument/2006/relationships" xmlns:p="http://schemas.openxmlformats.org/presentationml/2006/main">
   <p:cSld name="Slide 8">
+    <p:bg>
+      <p:bgPr>
+        <a:solidFill>
+          <a:srgbClr val="F4F9FA"/>
+        </a:solidFill>
+      </p:bgPr>
+    </p:bg>
+    <p:spTree>
+      <p:nvGrpSpPr>
+        <p:cNvPr id="1" name=""/>
+        <p:cNvGrpSpPr/>
+        <p:nvPr/>
+      </p:nvGrpSpPr>
+      <p:grpSpPr>
+        <a:xfrm>
+          <a:off x="0" y="0"/>
+          <a:ext cx="0" cy="0"/>
+          <a:chOff x="0" y="0"/>
+          <a:chExt cx="0" cy="0"/>
+        </a:xfrm>
+      </p:grpSpPr>
+      <p:sp>
+        <p:nvSpPr>
+          <p:cNvPr id="2" name="Text 0"/>
+          <p:cNvSpPr txBox="1"/>
+          <p:nvPr/>
+        </p:nvSpPr>
+        <p:spPr>
+          <a:xfrm>
+            <a:off x="457200" y="182880"/>
+            <a:ext cx="5486400" cy="201168"/>
+          </a:xfrm>
+          <a:prstGeom prst="rect">
+            <a:avLst/>
+          </a:prstGeom>
+          <a:noFill/>
+          <a:ln/>
+        </p:spPr>
+        <p:txBody>
+          <a:bodyPr wrap="square" lIns="0" tIns="0" rIns="0" bIns="0" rtlCol="0" anchor="ctr"/>
+          <a:lstStyle/>
+          <a:p>
+            <a:pPr indent="0" marL="0">
+              <a:buNone/>
+            </a:pPr>
+            <a:r>
+              <a:rPr lang="en-US" sz="850" b="1" spc="250" kern="0" dirty="0">
+                <a:solidFill>
+                  <a:srgbClr val="00606E"/>
+                </a:solidFill>
+                <a:latin typeface="Calibri" pitchFamily="34" charset="0"/>
+                <a:ea typeface="Calibri" pitchFamily="34" charset="-122"/>
+                <a:cs typeface="Calibri" pitchFamily="34" charset="-120"/>
+              </a:rPr>
+              <a:t>WHY IT MATTERS</a:t>
+            </a:r>
+            <a:endParaRPr lang="en-US" sz="850" dirty="0"/>
+          </a:p>
+        </p:txBody>
+      </p:sp>
+      <p:sp>
+        <p:nvSpPr>
+          <p:cNvPr id="3" name="Text 1"/>
+          <p:cNvSpPr txBox="1"/>
+          <p:nvPr/>
+        </p:nvSpPr>
+        <p:spPr>
+          <a:xfrm>
+            <a:off x="457200" y="411480"/>
+            <a:ext cx="8229600" cy="658368"/>
+          </a:xfrm>
+          <a:prstGeom prst="rect">
+            <a:avLst/>
+          </a:prstGeom>
+          <a:noFill/>
+          <a:ln/>
+        </p:spPr>
+        <p:txBody>
+          <a:bodyPr wrap="square" lIns="0" tIns="0" rIns="0" bIns="0" rtlCol="0" anchor="ctr"/>
+          <a:lstStyle/>
+          <a:p>
+            <a:pPr indent="0" marL="0">
+              <a:buNone/>
+            </a:pPr>
+            <a:r>
+              <a:rPr lang="en-US" sz="2800" b="1" dirty="0">
+                <a:solidFill>
+                  <a:srgbClr val="002D4A"/>
+                </a:solidFill>
+                <a:latin typeface="Calibri" pitchFamily="34" charset="0"/>
+                <a:ea typeface="Calibri" pitchFamily="34" charset="-122"/>
+                <a:cs typeface="Calibri" pitchFamily="34" charset="-120"/>
+              </a:rPr>
+              <a:t>Built for Patient Safety and Accountability</a:t>
+            </a:r>
+            <a:endParaRPr lang="en-US" sz="2800" dirty="0"/>
+          </a:p>
+        </p:txBody>
+      </p:sp>
+      <p:sp>
+        <p:nvSpPr>
+          <p:cNvPr id="4" name="Shape 2"/>
+          <p:cNvSpPr/>
+          <p:nvPr/>
+        </p:nvSpPr>
+        <p:spPr>
+          <a:xfrm>
+            <a:off x="411480" y="1143000"/>
+            <a:ext cx="4206240" cy="1600200"/>
+          </a:xfrm>
+          <a:prstGeom prst="roundRect">
+            <a:avLst>
+              <a:gd name="adj" fmla="val 4571"/>
+            </a:avLst>
+          </a:prstGeom>
+          <a:solidFill>
+            <a:srgbClr val="FFFFFF"/>
+          </a:solidFill>
+          <a:ln w="12700">
+            <a:solidFill>
+              <a:srgbClr val="C8E0E6"/>
+            </a:solidFill>
+            <a:prstDash val="solid"/>
+          </a:ln>
+        </p:spPr>
+      </p:sp>
+      <p:sp>
+        <p:nvSpPr>
+          <p:cNvPr id="5" name="Shape 3"/>
+          <p:cNvSpPr/>
+          <p:nvPr/>
+        </p:nvSpPr>
+        <p:spPr>
+          <a:xfrm>
+            <a:off x="612648" y="1719072"/>
+            <a:ext cx="475488" cy="475488"/>
+          </a:xfrm>
+          <a:prstGeom prst="ellipse">
+            <a:avLst/>
+          </a:prstGeom>
+          <a:solidFill>
+            <a:srgbClr val="00606E"/>
+          </a:solidFill>
+          <a:ln w="12700">
+            <a:solidFill>
+              <a:srgbClr val="00606E"/>
+            </a:solidFill>
+            <a:prstDash val="solid"/>
+          </a:ln>
+        </p:spPr>
+      </p:sp>
+      <p:sp>
+        <p:nvSpPr>
+          <p:cNvPr id="6" name="Text 4"/>
+          <p:cNvSpPr txBox="1"/>
+          <p:nvPr/>
+        </p:nvSpPr>
+        <p:spPr>
+          <a:xfrm>
+            <a:off x="612648" y="1719072"/>
+            <a:ext cx="475488" cy="475488"/>
+          </a:xfrm>
+          <a:prstGeom prst="rect">
+            <a:avLst/>
+          </a:prstGeom>
+          <a:noFill/>
+          <a:ln/>
+        </p:spPr>
+        <p:txBody>
+          <a:bodyPr wrap="square" lIns="0" tIns="0" rIns="0" bIns="0" rtlCol="0" anchor="ctr"/>
+          <a:lstStyle/>
+          <a:p>
+            <a:pPr algn="ctr" indent="0" marL="0">
+              <a:buNone/>
+            </a:pPr>
+            <a:r>
+              <a:rPr lang="en-US" sz="900" b="1" dirty="0">
+                <a:solidFill>
+                  <a:srgbClr val="FFFFFF"/>
+                </a:solidFill>
+                <a:latin typeface="Calibri" pitchFamily="34" charset="0"/>
+                <a:ea typeface="Calibri" pitchFamily="34" charset="-122"/>
+                <a:cs typeface="Calibri" pitchFamily="34" charset="-120"/>
+              </a:rPr>
+              <a:t>S</a:t>
+            </a:r>
+            <a:endParaRPr lang="en-US" sz="900" dirty="0"/>
+          </a:p>
+        </p:txBody>
+      </p:sp>
+      <p:sp>
+        <p:nvSpPr>
+          <p:cNvPr id="7" name="Text 5"/>
+          <p:cNvSpPr txBox="1"/>
+          <p:nvPr/>
+        </p:nvSpPr>
+        <p:spPr>
+          <a:xfrm>
+            <a:off x="1216152" y="1307592"/>
+            <a:ext cx="3218688" cy="365760"/>
+          </a:xfrm>
+          <a:prstGeom prst="rect">
+            <a:avLst/>
+          </a:prstGeom>
+          <a:noFill/>
+          <a:ln/>
+        </p:spPr>
+        <p:txBody>
+          <a:bodyPr wrap="square" lIns="0" tIns="0" rIns="0" bIns="0" rtlCol="0" anchor="ctr"/>
+          <a:lstStyle/>
+          <a:p>
+            <a:pPr indent="0" marL="0">
+              <a:buNone/>
+            </a:pPr>
+            <a:r>
+              <a:rPr lang="en-US" sz="1350" b="1" dirty="0">
+                <a:solidFill>
+                  <a:srgbClr val="002D4A"/>
+                </a:solidFill>
+                <a:latin typeface="Calibri" pitchFamily="34" charset="0"/>
+                <a:ea typeface="Calibri" pitchFamily="34" charset="-122"/>
+                <a:cs typeface="Calibri" pitchFamily="34" charset="-120"/>
+              </a:rPr>
+              <a:t>Safer instruments</a:t>
+            </a:r>
+            <a:endParaRPr lang="en-US" sz="1350" dirty="0"/>
+          </a:p>
+        </p:txBody>
+      </p:sp>
+      <p:sp>
+        <p:nvSpPr>
+          <p:cNvPr id="8" name="Text 6"/>
+          <p:cNvSpPr txBox="1"/>
+          <p:nvPr/>
+        </p:nvSpPr>
+        <p:spPr>
+          <a:xfrm>
+            <a:off x="1216152" y="1728216"/>
+            <a:ext cx="3218688" cy="877824"/>
+          </a:xfrm>
+          <a:prstGeom prst="rect">
+            <a:avLst/>
+          </a:prstGeom>
+          <a:noFill/>
+          <a:ln/>
+        </p:spPr>
+        <p:txBody>
+          <a:bodyPr wrap="square" lIns="0" tIns="0" rIns="0" bIns="0" rtlCol="0" anchor="ctr"/>
+          <a:lstStyle/>
+          <a:p>
+            <a:pPr indent="0" marL="0">
+              <a:buNone/>
+            </a:pPr>
+            <a:r>
+              <a:rPr lang="en-US" sz="1100" dirty="0">
+                <a:solidFill>
+                  <a:srgbClr val="4A5568"/>
+                </a:solidFill>
+                <a:latin typeface="Calibri" pitchFamily="34" charset="0"/>
+                <a:ea typeface="Calibri" pitchFamily="34" charset="-122"/>
+                <a:cs typeface="Calibri" pitchFamily="34" charset="-120"/>
+              </a:rPr>
+              <a:t>Real-time use counts and status flags mean instruments are never unknowingly overused or overlooked.</a:t>
+            </a:r>
+            <a:endParaRPr lang="en-US" sz="1100" dirty="0"/>
+          </a:p>
+        </p:txBody>
+      </p:sp>
+      <p:sp>
+        <p:nvSpPr>
+          <p:cNvPr id="9" name="Shape 7"/>
+          <p:cNvSpPr/>
+          <p:nvPr/>
+        </p:nvSpPr>
+        <p:spPr>
+          <a:xfrm>
+            <a:off x="4800600" y="1143000"/>
+            <a:ext cx="4206240" cy="1600200"/>
+          </a:xfrm>
+          <a:prstGeom prst="roundRect">
+            <a:avLst>
+              <a:gd name="adj" fmla="val 4571"/>
+            </a:avLst>
+          </a:prstGeom>
+          <a:solidFill>
+            <a:srgbClr val="FFFFFF"/>
+          </a:solidFill>
+          <a:ln w="12700">
+            <a:solidFill>
+              <a:srgbClr val="C8E0E6"/>
+            </a:solidFill>
+            <a:prstDash val="solid"/>
+          </a:ln>
+        </p:spPr>
+      </p:sp>
+      <p:sp>
+        <p:nvSpPr>
+          <p:cNvPr id="10" name="Shape 8"/>
+          <p:cNvSpPr/>
+          <p:nvPr/>
+        </p:nvSpPr>
+        <p:spPr>
+          <a:xfrm>
+            <a:off x="5001768" y="1719072"/>
+            <a:ext cx="475488" cy="475488"/>
+          </a:xfrm>
+          <a:prstGeom prst="ellipse">
+            <a:avLst/>
+          </a:prstGeom>
+          <a:solidFill>
+            <a:srgbClr val="1A7A52"/>
+          </a:solidFill>
+          <a:ln w="12700">
+            <a:solidFill>
+              <a:srgbClr val="1A7A52"/>
+            </a:solidFill>
+            <a:prstDash val="solid"/>
+          </a:ln>
+        </p:spPr>
+      </p:sp>
+      <p:sp>
+        <p:nvSpPr>
+          <p:cNvPr id="11" name="Text 9"/>
+          <p:cNvSpPr txBox="1"/>
+          <p:nvPr/>
+        </p:nvSpPr>
+        <p:spPr>
+          <a:xfrm>
+            <a:off x="5001768" y="1719072"/>
+            <a:ext cx="475488" cy="475488"/>
+          </a:xfrm>
+          <a:prstGeom prst="rect">
+            <a:avLst/>
+          </a:prstGeom>
+          <a:noFill/>
+          <a:ln/>
+        </p:spPr>
+        <p:txBody>
+          <a:bodyPr wrap="square" lIns="0" tIns="0" rIns="0" bIns="0" rtlCol="0" anchor="ctr"/>
+          <a:lstStyle/>
+          <a:p>
+            <a:pPr algn="ctr" indent="0" marL="0">
+              <a:buNone/>
+            </a:pPr>
+            <a:r>
+              <a:rPr lang="en-US" sz="900" b="1" dirty="0">
+                <a:solidFill>
+                  <a:srgbClr val="FFFFFF"/>
+                </a:solidFill>
+                <a:latin typeface="Calibri" pitchFamily="34" charset="0"/>
+                <a:ea typeface="Calibri" pitchFamily="34" charset="-122"/>
+                <a:cs typeface="Calibri" pitchFamily="34" charset="-120"/>
+              </a:rPr>
+              <a:t>A</a:t>
+            </a:r>
+            <a:endParaRPr lang="en-US" sz="900" dirty="0"/>
+          </a:p>
+        </p:txBody>
+      </p:sp>
+      <p:sp>
+        <p:nvSpPr>
+          <p:cNvPr id="12" name="Text 10"/>
+          <p:cNvSpPr txBox="1"/>
+          <p:nvPr/>
+        </p:nvSpPr>
+        <p:spPr>
+          <a:xfrm>
+            <a:off x="5605272" y="1307592"/>
+            <a:ext cx="3218688" cy="365760"/>
+          </a:xfrm>
+          <a:prstGeom prst="rect">
+            <a:avLst/>
+          </a:prstGeom>
+          <a:noFill/>
+          <a:ln/>
+        </p:spPr>
+        <p:txBody>
+          <a:bodyPr wrap="square" lIns="0" tIns="0" rIns="0" bIns="0" rtlCol="0" anchor="ctr"/>
+          <a:lstStyle/>
+          <a:p>
+            <a:pPr indent="0" marL="0">
+              <a:buNone/>
+            </a:pPr>
+            <a:r>
+              <a:rPr lang="en-US" sz="1350" b="1" dirty="0">
+                <a:solidFill>
+                  <a:srgbClr val="002D4A"/>
+                </a:solidFill>
+                <a:latin typeface="Calibri" pitchFamily="34" charset="0"/>
+                <a:ea typeface="Calibri" pitchFamily="34" charset="-122"/>
+                <a:cs typeface="Calibri" pitchFamily="34" charset="-120"/>
+              </a:rPr>
+              <a:t>Airtight audit trail</a:t>
+            </a:r>
+            <a:endParaRPr lang="en-US" sz="1350" dirty="0"/>
+          </a:p>
+        </p:txBody>
+      </p:sp>
+      <p:sp>
+        <p:nvSpPr>
+          <p:cNvPr id="13" name="Text 11"/>
+          <p:cNvSpPr txBox="1"/>
+          <p:nvPr/>
+        </p:nvSpPr>
+        <p:spPr>
+          <a:xfrm>
+            <a:off x="5605272" y="1728216"/>
+            <a:ext cx="3218688" cy="877824"/>
+          </a:xfrm>
+          <a:prstGeom prst="rect">
+            <a:avLst/>
+          </a:prstGeom>
+          <a:noFill/>
+          <a:ln/>
+        </p:spPr>
+        <p:txBody>
+          <a:bodyPr wrap="square" lIns="0" tIns="0" rIns="0" bIns="0" rtlCol="0" anchor="ctr"/>
+          <a:lstStyle/>
+          <a:p>
+            <a:pPr indent="0" marL="0">
+              <a:buNone/>
+            </a:pPr>
+            <a:r>
+              <a:rPr lang="en-US" sz="1100" dirty="0">
+                <a:solidFill>
+                  <a:srgbClr val="4A5568"/>
+                </a:solidFill>
+                <a:latin typeface="Calibri" pitchFamily="34" charset="0"/>
+                <a:ea typeface="Calibri" pitchFamily="34" charset="-122"/>
+                <a:cs typeface="Calibri" pitchFamily="34" charset="-120"/>
+              </a:rPr>
+              <a:t>Every action is permanently recorded, making incident review fast, accurate, and trustworthy.</a:t>
+            </a:r>
+            <a:endParaRPr lang="en-US" sz="1100" dirty="0"/>
+          </a:p>
+        </p:txBody>
+      </p:sp>
+      <p:sp>
+        <p:nvSpPr>
+          <p:cNvPr id="14" name="Shape 12"/>
+          <p:cNvSpPr/>
+          <p:nvPr/>
+        </p:nvSpPr>
+        <p:spPr>
+          <a:xfrm>
+            <a:off x="411480" y="2944368"/>
+            <a:ext cx="4206240" cy="1600200"/>
+          </a:xfrm>
+          <a:prstGeom prst="roundRect">
+            <a:avLst>
+              <a:gd name="adj" fmla="val 4571"/>
+            </a:avLst>
+          </a:prstGeom>
+          <a:solidFill>
+            <a:srgbClr val="FFFFFF"/>
+          </a:solidFill>
+          <a:ln w="12700">
+            <a:solidFill>
+              <a:srgbClr val="C8E0E6"/>
+            </a:solidFill>
+            <a:prstDash val="solid"/>
+          </a:ln>
+        </p:spPr>
+      </p:sp>
+      <p:sp>
+        <p:nvSpPr>
+          <p:cNvPr id="15" name="Shape 13"/>
+          <p:cNvSpPr/>
+          <p:nvPr/>
+        </p:nvSpPr>
+        <p:spPr>
+          <a:xfrm>
+            <a:off x="612648" y="3520440"/>
+            <a:ext cx="475488" cy="475488"/>
+          </a:xfrm>
+          <a:prstGeom prst="ellipse">
+            <a:avLst/>
+          </a:prstGeom>
+          <a:solidFill>
+            <a:srgbClr val="002D4A"/>
+          </a:solidFill>
+          <a:ln w="12700">
+            <a:solidFill>
+              <a:srgbClr val="002D4A"/>
+            </a:solidFill>
+            <a:prstDash val="solid"/>
+          </a:ln>
+        </p:spPr>
+      </p:sp>
+      <p:sp>
+        <p:nvSpPr>
+          <p:cNvPr id="16" name="Text 14"/>
+          <p:cNvSpPr txBox="1"/>
+          <p:nvPr/>
+        </p:nvSpPr>
+        <p:spPr>
+          <a:xfrm>
+            <a:off x="612648" y="3520440"/>
+            <a:ext cx="475488" cy="475488"/>
+          </a:xfrm>
+          <a:prstGeom prst="rect">
+            <a:avLst/>
+          </a:prstGeom>
+          <a:noFill/>
+          <a:ln/>
+        </p:spPr>
+        <p:txBody>
+          <a:bodyPr wrap="square" lIns="0" tIns="0" rIns="0" bIns="0" rtlCol="0" anchor="ctr"/>
+          <a:lstStyle/>
+          <a:p>
+            <a:pPr algn="ctr" indent="0" marL="0">
+              <a:buNone/>
+            </a:pPr>
+            <a:r>
+              <a:rPr lang="en-US" sz="900" b="1" dirty="0">
+                <a:solidFill>
+                  <a:srgbClr val="FFFFFF"/>
+                </a:solidFill>
+                <a:latin typeface="Calibri" pitchFamily="34" charset="0"/>
+                <a:ea typeface="Calibri" pitchFamily="34" charset="-122"/>
+                <a:cs typeface="Calibri" pitchFamily="34" charset="-120"/>
+              </a:rPr>
+              <a:t>E</a:t>
+            </a:r>
+            <a:endParaRPr lang="en-US" sz="900" dirty="0"/>
+          </a:p>
+        </p:txBody>
+      </p:sp>
+      <p:sp>
+        <p:nvSpPr>
+          <p:cNvPr id="17" name="Text 15"/>
+          <p:cNvSpPr txBox="1"/>
+          <p:nvPr/>
+        </p:nvSpPr>
+        <p:spPr>
+          <a:xfrm>
+            <a:off x="1216152" y="3108960"/>
+            <a:ext cx="3218688" cy="365760"/>
+          </a:xfrm>
+          <a:prstGeom prst="rect">
+            <a:avLst/>
+          </a:prstGeom>
+          <a:noFill/>
+          <a:ln/>
+        </p:spPr>
+        <p:txBody>
+          <a:bodyPr wrap="square" lIns="0" tIns="0" rIns="0" bIns="0" rtlCol="0" anchor="ctr"/>
+          <a:lstStyle/>
+          <a:p>
+            <a:pPr indent="0" marL="0">
+              <a:buNone/>
+            </a:pPr>
+            <a:r>
+              <a:rPr lang="en-US" sz="1350" b="1" dirty="0">
+                <a:solidFill>
+                  <a:srgbClr val="002D4A"/>
+                </a:solidFill>
+                <a:latin typeface="Calibri" pitchFamily="34" charset="0"/>
+                <a:ea typeface="Calibri" pitchFamily="34" charset="-122"/>
+                <a:cs typeface="Calibri" pitchFamily="34" charset="-120"/>
+              </a:rPr>
+              <a:t>Efficient operations</a:t>
+            </a:r>
+            <a:endParaRPr lang="en-US" sz="1350" dirty="0"/>
+          </a:p>
+        </p:txBody>
+      </p:sp>
+      <p:sp>
+        <p:nvSpPr>
+          <p:cNvPr id="18" name="Text 16"/>
+          <p:cNvSpPr txBox="1"/>
+          <p:nvPr/>
+        </p:nvSpPr>
+        <p:spPr>
+          <a:xfrm>
+            <a:off x="1216152" y="3529584"/>
+            <a:ext cx="3218688" cy="877824"/>
+          </a:xfrm>
+          <a:prstGeom prst="rect">
+            <a:avLst/>
+          </a:prstGeom>
+          <a:noFill/>
+          <a:ln/>
+        </p:spPr>
+        <p:txBody>
+          <a:bodyPr wrap="square" lIns="0" tIns="0" rIns="0" bIns="0" rtlCol="0" anchor="ctr"/>
+          <a:lstStyle/>
+          <a:p>
+            <a:pPr indent="0" marL="0">
+              <a:buNone/>
+            </a:pPr>
+            <a:r>
+              <a:rPr lang="en-US" sz="1100" dirty="0">
+                <a:solidFill>
+                  <a:srgbClr val="4A5568"/>
+                </a:solidFill>
+                <a:latin typeface="Calibri" pitchFamily="34" charset="0"/>
+                <a:ea typeface="Calibri" pitchFamily="34" charset="-122"/>
+                <a:cs typeface="Calibri" pitchFamily="34" charset="-120"/>
+              </a:rPr>
+              <a:t>Digital workflows replace manual paperwork, saving time and reducing transcription errors in busy OT sessions.</a:t>
+            </a:r>
+            <a:endParaRPr lang="en-US" sz="1100" dirty="0"/>
+          </a:p>
+        </p:txBody>
+      </p:sp>
+      <p:sp>
+        <p:nvSpPr>
+          <p:cNvPr id="19" name="Shape 17"/>
+          <p:cNvSpPr/>
+          <p:nvPr/>
+        </p:nvSpPr>
+        <p:spPr>
+          <a:xfrm>
+            <a:off x="4800600" y="2944368"/>
+            <a:ext cx="4206240" cy="1600200"/>
+          </a:xfrm>
+          <a:prstGeom prst="roundRect">
+            <a:avLst>
+              <a:gd name="adj" fmla="val 4571"/>
+            </a:avLst>
+          </a:prstGeom>
+          <a:solidFill>
+            <a:srgbClr val="FFFFFF"/>
+          </a:solidFill>
+          <a:ln w="12700">
+            <a:solidFill>
+              <a:srgbClr val="C8E0E6"/>
+            </a:solidFill>
+            <a:prstDash val="solid"/>
+          </a:ln>
+        </p:spPr>
+      </p:sp>
+      <p:sp>
+        <p:nvSpPr>
+          <p:cNvPr id="20" name="Shape 18"/>
+          <p:cNvSpPr/>
+          <p:nvPr/>
+        </p:nvSpPr>
+        <p:spPr>
+          <a:xfrm>
+            <a:off x="5001768" y="3520440"/>
+            <a:ext cx="475488" cy="475488"/>
+          </a:xfrm>
+          <a:prstGeom prst="ellipse">
+            <a:avLst/>
+          </a:prstGeom>
+          <a:solidFill>
+            <a:srgbClr val="8B2252"/>
+          </a:solidFill>
+          <a:ln w="12700">
+            <a:solidFill>
+              <a:srgbClr val="8B2252"/>
+            </a:solidFill>
+            <a:prstDash val="solid"/>
+          </a:ln>
+        </p:spPr>
+      </p:sp>
+      <p:sp>
+        <p:nvSpPr>
+          <p:cNvPr id="21" name="Text 19"/>
+          <p:cNvSpPr txBox="1"/>
+          <p:nvPr/>
+        </p:nvSpPr>
+        <p:spPr>
+          <a:xfrm>
+            <a:off x="5001768" y="3520440"/>
+            <a:ext cx="475488" cy="475488"/>
+          </a:xfrm>
+          <a:prstGeom prst="rect">
+            <a:avLst/>
+          </a:prstGeom>
+          <a:noFill/>
+          <a:ln/>
+        </p:spPr>
+        <p:txBody>
+          <a:bodyPr wrap="square" lIns="0" tIns="0" rIns="0" bIns="0" rtlCol="0" anchor="ctr"/>
+          <a:lstStyle/>
+          <a:p>
+            <a:pPr algn="ctr" indent="0" marL="0">
+              <a:buNone/>
+            </a:pPr>
+            <a:r>
+              <a:rPr lang="en-US" sz="900" b="1" dirty="0">
+                <a:solidFill>
+                  <a:srgbClr val="FFFFFF"/>
+                </a:solidFill>
+                <a:latin typeface="Calibri" pitchFamily="34" charset="0"/>
+                <a:ea typeface="Calibri" pitchFamily="34" charset="-122"/>
+                <a:cs typeface="Calibri" pitchFamily="34" charset="-120"/>
+              </a:rPr>
+              <a:t>R</a:t>
+            </a:r>
+            <a:endParaRPr lang="en-US" sz="900" dirty="0"/>
+          </a:p>
+        </p:txBody>
+      </p:sp>
+      <p:sp>
+        <p:nvSpPr>
+          <p:cNvPr id="22" name="Text 20"/>
+          <p:cNvSpPr txBox="1"/>
+          <p:nvPr/>
+        </p:nvSpPr>
+        <p:spPr>
+          <a:xfrm>
+            <a:off x="5605272" y="3108960"/>
+            <a:ext cx="3218688" cy="365760"/>
+          </a:xfrm>
+          <a:prstGeom prst="rect">
+            <a:avLst/>
+          </a:prstGeom>
+          <a:noFill/>
+          <a:ln/>
+        </p:spPr>
+        <p:txBody>
+          <a:bodyPr wrap="square" lIns="0" tIns="0" rIns="0" bIns="0" rtlCol="0" anchor="ctr"/>
+          <a:lstStyle/>
+          <a:p>
+            <a:pPr indent="0" marL="0">
+              <a:buNone/>
+            </a:pPr>
+            <a:r>
+              <a:rPr lang="en-US" sz="1350" b="1" dirty="0">
+                <a:solidFill>
+                  <a:srgbClr val="002D4A"/>
+                </a:solidFill>
+                <a:latin typeface="Calibri" pitchFamily="34" charset="0"/>
+                <a:ea typeface="Calibri" pitchFamily="34" charset="-122"/>
+                <a:cs typeface="Calibri" pitchFamily="34" charset="-120"/>
+              </a:rPr>
+              <a:t>Reduced operational risk</a:t>
+            </a:r>
+            <a:endParaRPr lang="en-US" sz="1350" dirty="0"/>
+          </a:p>
+        </p:txBody>
+      </p:sp>
+      <p:sp>
+        <p:nvSpPr>
+          <p:cNvPr id="23" name="Text 21"/>
+          <p:cNvSpPr txBox="1"/>
+          <p:nvPr/>
+        </p:nvSpPr>
+        <p:spPr>
+          <a:xfrm>
+            <a:off x="5605272" y="3529584"/>
+            <a:ext cx="3218688" cy="877824"/>
+          </a:xfrm>
+          <a:prstGeom prst="rect">
+            <a:avLst/>
+          </a:prstGeom>
+          <a:noFill/>
+          <a:ln/>
+        </p:spPr>
+        <p:txBody>
+          <a:bodyPr wrap="square" lIns="0" tIns="0" rIns="0" bIns="0" rtlCol="0" anchor="ctr"/>
+          <a:lstStyle/>
+          <a:p>
+            <a:pPr indent="0" marL="0">
+              <a:buNone/>
+            </a:pPr>
+            <a:r>
+              <a:rPr lang="en-US" sz="1100" dirty="0">
+                <a:solidFill>
+                  <a:srgbClr val="4A5568"/>
+                </a:solidFill>
+                <a:latin typeface="Calibri" pitchFamily="34" charset="0"/>
+                <a:ea typeface="Calibri" pitchFamily="34" charset="-122"/>
+                <a:cs typeface="Calibri" pitchFamily="34" charset="-120"/>
+              </a:rPr>
+              <a:t>Proactive fault tracking and lifecycle alerts help prevent equipment failures before they happen.</a:t>
+            </a:r>
+            <a:endParaRPr lang="en-US" sz="1100" dirty="0"/>
+          </a:p>
+        </p:txBody>
+      </p:sp>
+    </p:spTree>
+  </p:cSld>
+  <p:clrMapOvr>
+    <a:masterClrMapping/>
+  </p:clrMapOvr>
+</p:sld>
+</file>
+
+<file path=ppt/slides/slide9.xml><?xml version="1.0" encoding="utf-8"?>
+<p:sld xmlns:a="http://schemas.openxmlformats.org/drawingml/2006/main" xmlns:r="http://schemas.openxmlformats.org/officeDocument/2006/relationships" xmlns:p="http://schemas.openxmlformats.org/presentationml/2006/main">
+  <p:cSld name="Slide 9">
     <p:bg>
       <p:bgPr>
         <a:solidFill>
@@ -6711,8 +7867,8 @@
         </p:nvSpPr>
         <p:spPr>
           <a:xfrm>
-            <a:off x="2286000" y="685800"/>
-            <a:ext cx="4572000" cy="1645920"/>
+            <a:off x="2286000" y="1005840"/>
+            <a:ext cx="4572000" cy="1188720"/>
           </a:xfrm>
           <a:prstGeom prst="rect">
             <a:avLst/>
@@ -6750,8 +7906,8 @@
         </p:nvSpPr>
         <p:spPr>
           <a:xfrm>
-            <a:off x="1371600" y="2331720"/>
-            <a:ext cx="6400800" cy="411480"/>
+            <a:off x="1371600" y="2240280"/>
+            <a:ext cx="6400800" cy="384048"/>
           </a:xfrm>
           <a:prstGeom prst="rect">
             <a:avLst/>
@@ -6789,7 +7945,7 @@
         </p:nvSpPr>
         <p:spPr>
           <a:xfrm>
-            <a:off x="1828800" y="2834640"/>
+            <a:off x="1828800" y="2697480"/>
             <a:ext cx="5486400" cy="320040"/>
           </a:xfrm>
           <a:prstGeom prst="rect">
@@ -6828,7 +7984,7 @@
         </p:nvSpPr>
         <p:spPr>
           <a:xfrm>
-            <a:off x="1828800" y="3401568"/>
+            <a:off x="1828800" y="3154680"/>
             <a:ext cx="5486400" cy="384048"/>
           </a:xfrm>
           <a:prstGeom prst="rect">
@@ -6867,8 +8023,8 @@
         </p:nvSpPr>
         <p:spPr>
           <a:xfrm>
-            <a:off x="2286000" y="4160520"/>
-            <a:ext cx="4572000" cy="274320"/>
+            <a:off x="1828800" y="3657600"/>
+            <a:ext cx="5486400" cy="320040"/>
           </a:xfrm>
           <a:prstGeom prst="rect">
             <a:avLst/>
@@ -6884,9 +8040,9 @@
               <a:buNone/>
             </a:pPr>
             <a:r>
-              <a:rPr lang="en-US" sz="1000" dirty="0">
-                <a:solidFill>
-                  <a:srgbClr val="3A6870"/>
+              <a:rPr lang="en-US" sz="1150" dirty="0">
+                <a:solidFill>
+                  <a:srgbClr val="A0D0D8"/>
                 </a:solidFill>
                 <a:latin typeface="Calibri" pitchFamily="34" charset="0"/>
                 <a:ea typeface="Calibri" pitchFamily="34" charset="-122"/>
@@ -6894,7 +8050,7 @@
               </a:rPr>
               <a:t>Questions? Contact the RISE team.</a:t>
             </a:r>
-            <a:endParaRPr lang="en-US" sz="1000" dirty="0"/>
+            <a:endParaRPr lang="en-US" sz="1150" dirty="0"/>
           </a:p>
         </p:txBody>
       </p:sp>

</xml_diff>